<commit_message>
Expand slide 4 with Tiny Post + Gen Z snail mail revival proof points
Adds The Tiny Post (5K subs, $45K/mo, zero paid ads), Analog Life
Snail Society (25→1,600 members in one month), and Gen Z market stats
(150K+ #snailmail TikTok posts, 63% disconnecting digitally) to the
market proof slide. Restructured from 4-card to 6-card 3×2 grid with
top highlight strip.

https://claude.ai/code/session_01CLjwbj5nXTNesYSPGcg1qG
</commit_message>
<xml_diff>
--- a/K3C_Pitch_Deck.pptx
+++ b/K3C_Pitch_Deck.pptx
@@ -10974,7 +10974,7 @@
         <p:spPr>
           <a:xfrm>
             <a:off x="457200" y="502920"/>
-            <a:ext cx="5486400" cy="365760"/>
+            <a:ext cx="8229600" cy="365760"/>
           </a:xfrm>
           <a:prstGeom prst="rect">
             <a:avLst/>
@@ -11007,28 +11007,28 @@
         </p:nvSpPr>
         <p:spPr>
           <a:xfrm>
-            <a:off x="457200" y="914400"/>
-            <a:ext cx="7315200" cy="822960"/>
-          </a:xfrm>
-          <a:prstGeom prst="rect">
-            <a:avLst/>
-          </a:prstGeom>
-          <a:noFill/>
-        </p:spPr>
-        <p:txBody>
-          <a:bodyPr wrap="square">
-            <a:spAutoFit/>
-          </a:bodyPr>
-          <a:lstStyle/>
-          <a:p>
-            <a:pPr algn="l"/>
-            <a:r>
-              <a:rPr sz="4200" b="1" i="0">
+            <a:off x="457200" y="868680"/>
+            <a:ext cx="9144000" cy="685800"/>
+          </a:xfrm>
+          <a:prstGeom prst="rect">
+            <a:avLst/>
+          </a:prstGeom>
+          <a:noFill/>
+        </p:spPr>
+        <p:txBody>
+          <a:bodyPr wrap="square">
+            <a:spAutoFit/>
+          </a:bodyPr>
+          <a:lstStyle/>
+          <a:p>
+            <a:pPr algn="l"/>
+            <a:r>
+              <a:rPr sz="3800" b="1" i="0">
                 <a:solidFill>
                   <a:srgbClr val="FFFFFF"/>
                 </a:solidFill>
               </a:rPr>
-              <a:t>People crave real mail.</a:t>
+              <a:t>The mail revival is already happening.</a:t>
             </a:r>
           </a:p>
         </p:txBody>
@@ -11041,8 +11041,8 @@
         </p:nvSpPr>
         <p:spPr>
           <a:xfrm>
-            <a:off x="457200" y="1691640"/>
-            <a:ext cx="3657600" cy="45720"/>
+            <a:off x="457200" y="1536192"/>
+            <a:ext cx="5029200" cy="45720"/>
           </a:xfrm>
           <a:prstGeom prst="rect">
             <a:avLst/>
@@ -11084,8 +11084,8 @@
         </p:nvSpPr>
         <p:spPr>
           <a:xfrm>
-            <a:off x="457200" y="2011680"/>
-            <a:ext cx="5394960" cy="1920240"/>
+            <a:off x="457200" y="1664208"/>
+            <a:ext cx="3657600" cy="1078992"/>
           </a:xfrm>
           <a:prstGeom prst="roundRect">
             <a:avLst>
@@ -11093,7 +11093,7 @@
             </a:avLst>
           </a:prstGeom>
           <a:solidFill>
-            <a:srgbClr val="123A3A"/>
+            <a:srgbClr val="28807D"/>
           </a:solidFill>
           <a:ln>
             <a:noFill/>
@@ -11129,28 +11129,28 @@
         </p:nvSpPr>
         <p:spPr>
           <a:xfrm>
-            <a:off x="640080" y="2148840"/>
-            <a:ext cx="822960" cy="731520"/>
-          </a:xfrm>
-          <a:prstGeom prst="rect">
-            <a:avLst/>
-          </a:prstGeom>
-          <a:noFill/>
-        </p:spPr>
-        <p:txBody>
-          <a:bodyPr wrap="square">
-            <a:spAutoFit/>
-          </a:bodyPr>
-          <a:lstStyle/>
-          <a:p>
-            <a:pPr algn="l"/>
-            <a:r>
-              <a:rPr sz="3600" b="0" i="0">
-                <a:solidFill>
-                  <a:srgbClr val="FFFFFF"/>
-                </a:solidFill>
-              </a:rPr>
-              <a:t>📮</a:t>
+            <a:off x="621792" y="1737360"/>
+            <a:ext cx="1463040" cy="658368"/>
+          </a:xfrm>
+          <a:prstGeom prst="rect">
+            <a:avLst/>
+          </a:prstGeom>
+          <a:noFill/>
+        </p:spPr>
+        <p:txBody>
+          <a:bodyPr wrap="square">
+            <a:spAutoFit/>
+          </a:bodyPr>
+          <a:lstStyle/>
+          <a:p>
+            <a:pPr algn="l"/>
+            <a:r>
+              <a:rPr sz="3600" b="1" i="0">
+                <a:solidFill>
+                  <a:srgbClr val="4CC8C3"/>
+                </a:solidFill>
+              </a:rPr>
+              <a:t>150K+</a:t>
             </a:r>
           </a:p>
         </p:txBody>
@@ -11163,145 +11163,43 @@
         </p:nvSpPr>
         <p:spPr>
           <a:xfrm>
-            <a:off x="1463040" y="2121408"/>
-            <a:ext cx="2743200" cy="640080"/>
-          </a:xfrm>
-          <a:prstGeom prst="rect">
-            <a:avLst/>
-          </a:prstGeom>
-          <a:noFill/>
-        </p:spPr>
-        <p:txBody>
-          <a:bodyPr wrap="square">
-            <a:spAutoFit/>
-          </a:bodyPr>
-          <a:lstStyle/>
-          <a:p>
-            <a:pPr algn="l"/>
-            <a:r>
-              <a:rPr sz="3800" b="1" i="0">
-                <a:solidFill>
-                  <a:srgbClr val="4CC8C3"/>
-                </a:solidFill>
-              </a:rPr>
-              <a:t>806K+</a:t>
-            </a:r>
-          </a:p>
-        </p:txBody>
-      </p:sp>
-      <p:sp>
-        <p:nvSpPr>
-          <p:cNvPr id="9" name="TextBox 8"/>
-          <p:cNvSpPr txBox="1"/>
-          <p:nvPr/>
-        </p:nvSpPr>
-        <p:spPr>
-          <a:xfrm>
-            <a:off x="1463040" y="2697480"/>
-            <a:ext cx="2743200" cy="320040"/>
-          </a:xfrm>
-          <a:prstGeom prst="rect">
-            <a:avLst/>
-          </a:prstGeom>
-          <a:noFill/>
-        </p:spPr>
-        <p:txBody>
-          <a:bodyPr wrap="square">
-            <a:spAutoFit/>
-          </a:bodyPr>
-          <a:lstStyle/>
-          <a:p>
-            <a:pPr algn="l"/>
-            <a:r>
-              <a:rPr sz="1400" b="0" i="0">
-                <a:solidFill>
-                  <a:srgbClr val="A0E1DF"/>
-                </a:solidFill>
-              </a:rPr>
-              <a:t>members</a:t>
-            </a:r>
-          </a:p>
-        </p:txBody>
-      </p:sp>
-      <p:sp>
-        <p:nvSpPr>
-          <p:cNvPr id="10" name="TextBox 9"/>
-          <p:cNvSpPr txBox="1"/>
-          <p:nvPr/>
-        </p:nvSpPr>
-        <p:spPr>
-          <a:xfrm>
-            <a:off x="1463040" y="3017520"/>
-            <a:ext cx="2560320" cy="457200"/>
-          </a:xfrm>
-          <a:prstGeom prst="rect">
-            <a:avLst/>
-          </a:prstGeom>
-          <a:noFill/>
-        </p:spPr>
-        <p:txBody>
-          <a:bodyPr wrap="square">
-            <a:spAutoFit/>
-          </a:bodyPr>
-          <a:lstStyle/>
-          <a:p>
-            <a:pPr algn="l"/>
-            <a:r>
-              <a:rPr sz="1300" b="1" i="0">
-                <a:solidFill>
-                  <a:srgbClr val="FFFFFF"/>
-                </a:solidFill>
-              </a:rPr>
-              <a:t>Postcrossing</a:t>
-            </a:r>
-          </a:p>
-        </p:txBody>
-      </p:sp>
-      <p:sp>
-        <p:nvSpPr>
-          <p:cNvPr id="11" name="TextBox 10"/>
-          <p:cNvSpPr txBox="1"/>
-          <p:nvPr/>
-        </p:nvSpPr>
-        <p:spPr>
-          <a:xfrm>
-            <a:off x="3931920" y="2194560"/>
-            <a:ext cx="1737360" cy="1554480"/>
-          </a:xfrm>
-          <a:prstGeom prst="rect">
-            <a:avLst/>
-          </a:prstGeom>
-          <a:noFill/>
-        </p:spPr>
-        <p:txBody>
-          <a:bodyPr wrap="square">
-            <a:spAutoFit/>
-          </a:bodyPr>
-          <a:lstStyle/>
-          <a:p>
-            <a:pPr algn="l"/>
-            <a:r>
-              <a:rPr sz="1100" b="0" i="0">
-                <a:solidFill>
-                  <a:srgbClr val="88AAA8"/>
-                </a:solidFill>
-              </a:rPr>
-              <a:t>87M+ postcards exchanged
-worldwide</a:t>
-            </a:r>
-          </a:p>
-        </p:txBody>
-      </p:sp>
-      <p:sp>
-        <p:nvSpPr>
-          <p:cNvPr id="12" name="Rounded Rectangle 11"/>
+            <a:off x="2148840" y="1792224"/>
+            <a:ext cx="1828800" cy="822960"/>
+          </a:xfrm>
+          <a:prstGeom prst="rect">
+            <a:avLst/>
+          </a:prstGeom>
+          <a:noFill/>
+        </p:spPr>
+        <p:txBody>
+          <a:bodyPr wrap="square">
+            <a:spAutoFit/>
+          </a:bodyPr>
+          <a:lstStyle/>
+          <a:p>
+            <a:pPr algn="l"/>
+            <a:r>
+              <a:rPr sz="1200" b="0" i="0">
+                <a:solidFill>
+                  <a:srgbClr val="E8F4F3"/>
+                </a:solidFill>
+              </a:rPr>
+              <a:t>TikTok posts
+tagged #snailmail</a:t>
+            </a:r>
+          </a:p>
+        </p:txBody>
+      </p:sp>
+      <p:sp>
+        <p:nvSpPr>
+          <p:cNvPr id="9" name="Rounded Rectangle 8"/>
           <p:cNvSpPr/>
           <p:nvPr/>
         </p:nvSpPr>
         <p:spPr>
           <a:xfrm>
-            <a:off x="6217920" y="2011680"/>
-            <a:ext cx="5394960" cy="1920240"/>
+            <a:off x="4343400" y="1664208"/>
+            <a:ext cx="3657600" cy="1078992"/>
           </a:xfrm>
           <a:prstGeom prst="roundRect">
             <a:avLst>
@@ -11309,7 +11207,7 @@
             </a:avLst>
           </a:prstGeom>
           <a:solidFill>
-            <a:srgbClr val="123A3A"/>
+            <a:srgbClr val="28807D"/>
           </a:solidFill>
           <a:ln>
             <a:noFill/>
@@ -11339,186 +11237,83 @@
       </p:sp>
       <p:sp>
         <p:nvSpPr>
-          <p:cNvPr id="13" name="TextBox 12"/>
-          <p:cNvSpPr txBox="1"/>
-          <p:nvPr/>
-        </p:nvSpPr>
-        <p:spPr>
-          <a:xfrm>
-            <a:off x="6400800" y="2148840"/>
-            <a:ext cx="822960" cy="731520"/>
-          </a:xfrm>
-          <a:prstGeom prst="rect">
-            <a:avLst/>
-          </a:prstGeom>
-          <a:noFill/>
-        </p:spPr>
-        <p:txBody>
-          <a:bodyPr wrap="square">
-            <a:spAutoFit/>
-          </a:bodyPr>
-          <a:lstStyle/>
-          <a:p>
-            <a:pPr algn="l"/>
-            <a:r>
-              <a:rPr sz="3600" b="0" i="0">
-                <a:solidFill>
-                  <a:srgbClr val="FFFFFF"/>
-                </a:solidFill>
-              </a:rPr>
-              <a:t>✉️</a:t>
-            </a:r>
-          </a:p>
-        </p:txBody>
-      </p:sp>
-      <p:sp>
-        <p:nvSpPr>
-          <p:cNvPr id="14" name="TextBox 13"/>
-          <p:cNvSpPr txBox="1"/>
-          <p:nvPr/>
-        </p:nvSpPr>
-        <p:spPr>
-          <a:xfrm>
-            <a:off x="7223760" y="2121408"/>
-            <a:ext cx="2743200" cy="640080"/>
-          </a:xfrm>
-          <a:prstGeom prst="rect">
-            <a:avLst/>
-          </a:prstGeom>
-          <a:noFill/>
-        </p:spPr>
-        <p:txBody>
-          <a:bodyPr wrap="square">
-            <a:spAutoFit/>
-          </a:bodyPr>
-          <a:lstStyle/>
-          <a:p>
-            <a:pPr algn="l"/>
-            <a:r>
-              <a:rPr sz="3800" b="1" i="0">
+          <p:cNvPr id="10" name="TextBox 9"/>
+          <p:cNvSpPr txBox="1"/>
+          <p:nvPr/>
+        </p:nvSpPr>
+        <p:spPr>
+          <a:xfrm>
+            <a:off x="4507992" y="1737360"/>
+            <a:ext cx="1463040" cy="658368"/>
+          </a:xfrm>
+          <a:prstGeom prst="rect">
+            <a:avLst/>
+          </a:prstGeom>
+          <a:noFill/>
+        </p:spPr>
+        <p:txBody>
+          <a:bodyPr wrap="square">
+            <a:spAutoFit/>
+          </a:bodyPr>
+          <a:lstStyle/>
+          <a:p>
+            <a:pPr algn="l"/>
+            <a:r>
+              <a:rPr sz="3600" b="1" i="0">
                 <a:solidFill>
                   <a:srgbClr val="4CC8C3"/>
                 </a:solidFill>
               </a:rPr>
-              <a:t>1M+</a:t>
-            </a:r>
-          </a:p>
-        </p:txBody>
-      </p:sp>
-      <p:sp>
-        <p:nvSpPr>
-          <p:cNvPr id="15" name="TextBox 14"/>
-          <p:cNvSpPr txBox="1"/>
-          <p:nvPr/>
-        </p:nvSpPr>
-        <p:spPr>
-          <a:xfrm>
-            <a:off x="7223760" y="2697480"/>
-            <a:ext cx="2743200" cy="320040"/>
-          </a:xfrm>
-          <a:prstGeom prst="rect">
-            <a:avLst/>
-          </a:prstGeom>
-          <a:noFill/>
-        </p:spPr>
-        <p:txBody>
-          <a:bodyPr wrap="square">
-            <a:spAutoFit/>
-          </a:bodyPr>
-          <a:lstStyle/>
-          <a:p>
-            <a:pPr algn="l"/>
-            <a:r>
-              <a:rPr sz="1400" b="0" i="0">
-                <a:solidFill>
-                  <a:srgbClr val="A0E1DF"/>
-                </a:solidFill>
-              </a:rPr>
-              <a:t>letters</a:t>
-            </a:r>
-          </a:p>
-        </p:txBody>
-      </p:sp>
-      <p:sp>
-        <p:nvSpPr>
-          <p:cNvPr id="16" name="TextBox 15"/>
-          <p:cNvSpPr txBox="1"/>
-          <p:nvPr/>
-        </p:nvSpPr>
-        <p:spPr>
-          <a:xfrm>
-            <a:off x="7223760" y="3017520"/>
-            <a:ext cx="2560320" cy="457200"/>
-          </a:xfrm>
-          <a:prstGeom prst="rect">
-            <a:avLst/>
-          </a:prstGeom>
-          <a:noFill/>
-        </p:spPr>
-        <p:txBody>
-          <a:bodyPr wrap="square">
-            <a:spAutoFit/>
-          </a:bodyPr>
-          <a:lstStyle/>
-          <a:p>
-            <a:pPr algn="l"/>
-            <a:r>
-              <a:rPr sz="1300" b="1" i="0">
-                <a:solidFill>
-                  <a:srgbClr val="FFFFFF"/>
-                </a:solidFill>
-              </a:rPr>
-              <a:t>Letters Against
-Isolation</a:t>
-            </a:r>
-          </a:p>
-        </p:txBody>
-      </p:sp>
-      <p:sp>
-        <p:nvSpPr>
-          <p:cNvPr id="17" name="TextBox 16"/>
-          <p:cNvSpPr txBox="1"/>
-          <p:nvPr/>
-        </p:nvSpPr>
-        <p:spPr>
-          <a:xfrm>
-            <a:off x="9692640" y="2194560"/>
-            <a:ext cx="1737360" cy="1554480"/>
-          </a:xfrm>
-          <a:prstGeom prst="rect">
-            <a:avLst/>
-          </a:prstGeom>
-          <a:noFill/>
-        </p:spPr>
-        <p:txBody>
-          <a:bodyPr wrap="square">
-            <a:spAutoFit/>
-          </a:bodyPr>
-          <a:lstStyle/>
-          <a:p>
-            <a:pPr algn="l"/>
-            <a:r>
-              <a:rPr sz="1100" b="0" i="0">
-                <a:solidFill>
-                  <a:srgbClr val="88AAA8"/>
-                </a:solidFill>
-              </a:rPr>
-              <a:t>Delivered during
-COVID isolation</a:t>
-            </a:r>
-          </a:p>
-        </p:txBody>
-      </p:sp>
-      <p:sp>
-        <p:nvSpPr>
-          <p:cNvPr id="18" name="Rounded Rectangle 17"/>
+              <a:t>63%</a:t>
+            </a:r>
+          </a:p>
+        </p:txBody>
+      </p:sp>
+      <p:sp>
+        <p:nvSpPr>
+          <p:cNvPr id="11" name="TextBox 10"/>
+          <p:cNvSpPr txBox="1"/>
+          <p:nvPr/>
+        </p:nvSpPr>
+        <p:spPr>
+          <a:xfrm>
+            <a:off x="6035040" y="1792224"/>
+            <a:ext cx="1828800" cy="822960"/>
+          </a:xfrm>
+          <a:prstGeom prst="rect">
+            <a:avLst/>
+          </a:prstGeom>
+          <a:noFill/>
+        </p:spPr>
+        <p:txBody>
+          <a:bodyPr wrap="square">
+            <a:spAutoFit/>
+          </a:bodyPr>
+          <a:lstStyle/>
+          <a:p>
+            <a:pPr algn="l"/>
+            <a:r>
+              <a:rPr sz="1200" b="0" i="0">
+                <a:solidFill>
+                  <a:srgbClr val="E8F4F3"/>
+                </a:solidFill>
+              </a:rPr>
+              <a:t>of Gen Z actively
+disconnecting digitally</a:t>
+            </a:r>
+          </a:p>
+        </p:txBody>
+      </p:sp>
+      <p:sp>
+        <p:nvSpPr>
+          <p:cNvPr id="12" name="Rounded Rectangle 11"/>
           <p:cNvSpPr/>
           <p:nvPr/>
         </p:nvSpPr>
         <p:spPr>
           <a:xfrm>
-            <a:off x="457200" y="4251960"/>
-            <a:ext cx="5394960" cy="1920240"/>
+            <a:off x="8229600" y="1664208"/>
+            <a:ext cx="3657600" cy="1078992"/>
           </a:xfrm>
           <a:prstGeom prst="roundRect">
             <a:avLst>
@@ -11526,7 +11321,7 @@
             </a:avLst>
           </a:prstGeom>
           <a:solidFill>
-            <a:srgbClr val="123A3A"/>
+            <a:srgbClr val="28807D"/>
           </a:solidFill>
           <a:ln>
             <a:noFill/>
@@ -11556,185 +11351,83 @@
       </p:sp>
       <p:sp>
         <p:nvSpPr>
-          <p:cNvPr id="19" name="TextBox 18"/>
-          <p:cNvSpPr txBox="1"/>
-          <p:nvPr/>
-        </p:nvSpPr>
-        <p:spPr>
-          <a:xfrm>
-            <a:off x="640080" y="4389120"/>
-            <a:ext cx="822960" cy="731520"/>
-          </a:xfrm>
-          <a:prstGeom prst="rect">
-            <a:avLst/>
-          </a:prstGeom>
-          <a:noFill/>
-        </p:spPr>
-        <p:txBody>
-          <a:bodyPr wrap="square">
-            <a:spAutoFit/>
-          </a:bodyPr>
-          <a:lstStyle/>
-          <a:p>
-            <a:pPr algn="l"/>
-            <a:r>
-              <a:rPr sz="3600" b="0" i="0">
-                <a:solidFill>
-                  <a:srgbClr val="FFFFFF"/>
-                </a:solidFill>
-              </a:rPr>
-              <a:t>💌</a:t>
-            </a:r>
-          </a:p>
-        </p:txBody>
-      </p:sp>
-      <p:sp>
-        <p:nvSpPr>
-          <p:cNvPr id="20" name="TextBox 19"/>
-          <p:cNvSpPr txBox="1"/>
-          <p:nvPr/>
-        </p:nvSpPr>
-        <p:spPr>
-          <a:xfrm>
-            <a:off x="1463040" y="4361688"/>
-            <a:ext cx="2743200" cy="640080"/>
-          </a:xfrm>
-          <a:prstGeom prst="rect">
-            <a:avLst/>
-          </a:prstGeom>
-          <a:noFill/>
-        </p:spPr>
-        <p:txBody>
-          <a:bodyPr wrap="square">
-            <a:spAutoFit/>
-          </a:bodyPr>
-          <a:lstStyle/>
-          <a:p>
-            <a:pPr algn="l"/>
-            <a:r>
-              <a:rPr sz="3800" b="1" i="0">
+          <p:cNvPr id="13" name="TextBox 12"/>
+          <p:cNvSpPr txBox="1"/>
+          <p:nvPr/>
+        </p:nvSpPr>
+        <p:spPr>
+          <a:xfrm>
+            <a:off x="8394192" y="1737360"/>
+            <a:ext cx="1463040" cy="658368"/>
+          </a:xfrm>
+          <a:prstGeom prst="rect">
+            <a:avLst/>
+          </a:prstGeom>
+          <a:noFill/>
+        </p:spPr>
+        <p:txBody>
+          <a:bodyPr wrap="square">
+            <a:spAutoFit/>
+          </a:bodyPr>
+          <a:lstStyle/>
+          <a:p>
+            <a:pPr algn="l"/>
+            <a:r>
+              <a:rPr sz="3600" b="1" i="0">
                 <a:solidFill>
                   <a:srgbClr val="4CC8C3"/>
                 </a:solidFill>
               </a:rPr>
-              <a:t>1M+</a:t>
-            </a:r>
-          </a:p>
-        </p:txBody>
-      </p:sp>
-      <p:sp>
-        <p:nvSpPr>
-          <p:cNvPr id="21" name="TextBox 20"/>
-          <p:cNvSpPr txBox="1"/>
-          <p:nvPr/>
-        </p:nvSpPr>
-        <p:spPr>
-          <a:xfrm>
-            <a:off x="1463040" y="4937760"/>
-            <a:ext cx="2743200" cy="320040"/>
-          </a:xfrm>
-          <a:prstGeom prst="rect">
-            <a:avLst/>
-          </a:prstGeom>
-          <a:noFill/>
-        </p:spPr>
-        <p:txBody>
-          <a:bodyPr wrap="square">
-            <a:spAutoFit/>
-          </a:bodyPr>
-          <a:lstStyle/>
-          <a:p>
-            <a:pPr algn="l"/>
-            <a:r>
-              <a:rPr sz="1400" b="0" i="0">
-                <a:solidFill>
-                  <a:srgbClr val="A0E1DF"/>
-                </a:solidFill>
-              </a:rPr>
-              <a:t>letters sent</a:t>
-            </a:r>
-          </a:p>
-        </p:txBody>
-      </p:sp>
-      <p:sp>
-        <p:nvSpPr>
-          <p:cNvPr id="22" name="TextBox 21"/>
-          <p:cNvSpPr txBox="1"/>
-          <p:nvPr/>
-        </p:nvSpPr>
-        <p:spPr>
-          <a:xfrm>
-            <a:off x="1463040" y="5257800"/>
-            <a:ext cx="2560320" cy="457200"/>
-          </a:xfrm>
-          <a:prstGeom prst="rect">
-            <a:avLst/>
-          </a:prstGeom>
-          <a:noFill/>
-        </p:spPr>
-        <p:txBody>
-          <a:bodyPr wrap="square">
-            <a:spAutoFit/>
-          </a:bodyPr>
-          <a:lstStyle/>
-          <a:p>
-            <a:pPr algn="l"/>
-            <a:r>
-              <a:rPr sz="1300" b="1" i="0">
-                <a:solidFill>
-                  <a:srgbClr val="FFFFFF"/>
-                </a:solidFill>
-              </a:rPr>
-              <a:t>Love For Our Elders</a:t>
-            </a:r>
-          </a:p>
-        </p:txBody>
-      </p:sp>
-      <p:sp>
-        <p:nvSpPr>
-          <p:cNvPr id="23" name="TextBox 22"/>
-          <p:cNvSpPr txBox="1"/>
-          <p:nvPr/>
-        </p:nvSpPr>
-        <p:spPr>
-          <a:xfrm>
-            <a:off x="3931920" y="4434840"/>
-            <a:ext cx="1737360" cy="1554480"/>
-          </a:xfrm>
-          <a:prstGeom prst="rect">
-            <a:avLst/>
-          </a:prstGeom>
-          <a:noFill/>
-        </p:spPr>
-        <p:txBody>
-          <a:bodyPr wrap="square">
-            <a:spAutoFit/>
-          </a:bodyPr>
-          <a:lstStyle/>
-          <a:p>
-            <a:pPr algn="l"/>
-            <a:r>
-              <a:rPr sz="1100" b="0" i="0">
-                <a:solidFill>
-                  <a:srgbClr val="88AAA8"/>
-                </a:solidFill>
-              </a:rPr>
-              <a:t>100+ chapters,
-70+ mailboxes</a:t>
-            </a:r>
-          </a:p>
-        </p:txBody>
-      </p:sp>
-      <p:sp>
-        <p:nvSpPr>
-          <p:cNvPr id="24" name="Rounded Rectangle 23"/>
+              <a:t>$45K</a:t>
+            </a:r>
+          </a:p>
+        </p:txBody>
+      </p:sp>
+      <p:sp>
+        <p:nvSpPr>
+          <p:cNvPr id="14" name="TextBox 13"/>
+          <p:cNvSpPr txBox="1"/>
+          <p:nvPr/>
+        </p:nvSpPr>
+        <p:spPr>
+          <a:xfrm>
+            <a:off x="9921240" y="1792224"/>
+            <a:ext cx="1828800" cy="822960"/>
+          </a:xfrm>
+          <a:prstGeom prst="rect">
+            <a:avLst/>
+          </a:prstGeom>
+          <a:noFill/>
+        </p:spPr>
+        <p:txBody>
+          <a:bodyPr wrap="square">
+            <a:spAutoFit/>
+          </a:bodyPr>
+          <a:lstStyle/>
+          <a:p>
+            <a:pPr algn="l"/>
+            <a:r>
+              <a:rPr sz="1200" b="0" i="0">
+                <a:solidFill>
+                  <a:srgbClr val="E8F4F3"/>
+                </a:solidFill>
+              </a:rPr>
+              <a:t>revenue/mo — one
+snail mail club, zero paid ads</a:t>
+            </a:r>
+          </a:p>
+        </p:txBody>
+      </p:sp>
+      <p:sp>
+        <p:nvSpPr>
+          <p:cNvPr id="15" name="Rounded Rectangle 14"/>
           <p:cNvSpPr/>
           <p:nvPr/>
         </p:nvSpPr>
         <p:spPr>
           <a:xfrm>
-            <a:off x="6217920" y="4251960"/>
-            <a:ext cx="5394960" cy="1920240"/>
+            <a:off x="457200" y="2926080"/>
+            <a:ext cx="3749039" cy="1417320"/>
           </a:xfrm>
           <a:prstGeom prst="roundRect">
             <a:avLst>
@@ -11742,7 +11435,7 @@
             </a:avLst>
           </a:prstGeom>
           <a:solidFill>
-            <a:srgbClr val="123A3A"/>
+            <a:srgbClr val="103232"/>
           </a:solidFill>
           <a:ln>
             <a:noFill/>
@@ -11772,33 +11465,1112 @@
       </p:sp>
       <p:sp>
         <p:nvSpPr>
+          <p:cNvPr id="16" name="Rectangle 15"/>
+          <p:cNvSpPr/>
+          <p:nvPr/>
+        </p:nvSpPr>
+        <p:spPr>
+          <a:xfrm>
+            <a:off x="457200" y="2926080"/>
+            <a:ext cx="45720" cy="1417320"/>
+          </a:xfrm>
+          <a:prstGeom prst="rect">
+            <a:avLst/>
+          </a:prstGeom>
+          <a:solidFill>
+            <a:srgbClr val="4CC8C3"/>
+          </a:solidFill>
+          <a:ln>
+            <a:noFill/>
+          </a:ln>
+        </p:spPr>
+        <p:style>
+          <a:lnRef idx="1">
+            <a:schemeClr val="accent1"/>
+          </a:lnRef>
+          <a:fillRef idx="3">
+            <a:schemeClr val="accent1"/>
+          </a:fillRef>
+          <a:effectRef idx="2">
+            <a:schemeClr val="accent1"/>
+          </a:effectRef>
+          <a:fontRef idx="minor">
+            <a:schemeClr val="lt1"/>
+          </a:fontRef>
+        </p:style>
+        <p:txBody>
+          <a:bodyPr rtlCol="0" anchor="ctr"/>
+          <a:lstStyle/>
+          <a:p>
+            <a:pPr algn="ctr"/>
+          </a:p>
+        </p:txBody>
+      </p:sp>
+      <p:sp>
+        <p:nvSpPr>
+          <p:cNvPr id="17" name="TextBox 16"/>
+          <p:cNvSpPr txBox="1"/>
+          <p:nvPr/>
+        </p:nvSpPr>
+        <p:spPr>
+          <a:xfrm>
+            <a:off x="566928" y="3017520"/>
+            <a:ext cx="594360" cy="640080"/>
+          </a:xfrm>
+          <a:prstGeom prst="rect">
+            <a:avLst/>
+          </a:prstGeom>
+          <a:noFill/>
+        </p:spPr>
+        <p:txBody>
+          <a:bodyPr wrap="square">
+            <a:spAutoFit/>
+          </a:bodyPr>
+          <a:lstStyle/>
+          <a:p>
+            <a:pPr algn="l"/>
+            <a:r>
+              <a:rPr sz="2800" b="0" i="0">
+                <a:solidFill>
+                  <a:srgbClr val="FFFFFF"/>
+                </a:solidFill>
+              </a:rPr>
+              <a:t>✉️</a:t>
+            </a:r>
+          </a:p>
+        </p:txBody>
+      </p:sp>
+      <p:sp>
+        <p:nvSpPr>
+          <p:cNvPr id="18" name="TextBox 17"/>
+          <p:cNvSpPr txBox="1"/>
+          <p:nvPr/>
+        </p:nvSpPr>
+        <p:spPr>
+          <a:xfrm>
+            <a:off x="1234440" y="2999232"/>
+            <a:ext cx="1325880" cy="530352"/>
+          </a:xfrm>
+          <a:prstGeom prst="rect">
+            <a:avLst/>
+          </a:prstGeom>
+          <a:noFill/>
+        </p:spPr>
+        <p:txBody>
+          <a:bodyPr wrap="square">
+            <a:spAutoFit/>
+          </a:bodyPr>
+          <a:lstStyle/>
+          <a:p>
+            <a:pPr algn="l"/>
+            <a:r>
+              <a:rPr sz="3000" b="1" i="0">
+                <a:solidFill>
+                  <a:srgbClr val="4CC8C3"/>
+                </a:solidFill>
+              </a:rPr>
+              <a:t>5,000</a:t>
+            </a:r>
+          </a:p>
+        </p:txBody>
+      </p:sp>
+      <p:sp>
+        <p:nvSpPr>
+          <p:cNvPr id="19" name="TextBox 18"/>
+          <p:cNvSpPr txBox="1"/>
+          <p:nvPr/>
+        </p:nvSpPr>
+        <p:spPr>
+          <a:xfrm>
+            <a:off x="1234440" y="3493008"/>
+            <a:ext cx="1463040" cy="274320"/>
+          </a:xfrm>
+          <a:prstGeom prst="rect">
+            <a:avLst/>
+          </a:prstGeom>
+          <a:noFill/>
+        </p:spPr>
+        <p:txBody>
+          <a:bodyPr wrap="square">
+            <a:spAutoFit/>
+          </a:bodyPr>
+          <a:lstStyle/>
+          <a:p>
+            <a:pPr algn="l"/>
+            <a:r>
+              <a:rPr sz="1000" b="0" i="0">
+                <a:solidFill>
+                  <a:srgbClr val="A0E1DF"/>
+                </a:solidFill>
+              </a:rPr>
+              <a:t>paying subscribers</a:t>
+            </a:r>
+          </a:p>
+        </p:txBody>
+      </p:sp>
+      <p:sp>
+        <p:nvSpPr>
+          <p:cNvPr id="20" name="TextBox 19"/>
+          <p:cNvSpPr txBox="1"/>
+          <p:nvPr/>
+        </p:nvSpPr>
+        <p:spPr>
+          <a:xfrm>
+            <a:off x="2606040" y="2999232"/>
+            <a:ext cx="1508760" cy="347472"/>
+          </a:xfrm>
+          <a:prstGeom prst="rect">
+            <a:avLst/>
+          </a:prstGeom>
+          <a:noFill/>
+        </p:spPr>
+        <p:txBody>
+          <a:bodyPr wrap="square">
+            <a:spAutoFit/>
+          </a:bodyPr>
+          <a:lstStyle/>
+          <a:p>
+            <a:pPr algn="l"/>
+            <a:r>
+              <a:rPr sz="1200" b="1" i="0">
+                <a:solidFill>
+                  <a:srgbClr val="FFFFFF"/>
+                </a:solidFill>
+              </a:rPr>
+              <a:t>The Tiny Post</a:t>
+            </a:r>
+          </a:p>
+        </p:txBody>
+      </p:sp>
+      <p:sp>
+        <p:nvSpPr>
+          <p:cNvPr id="21" name="TextBox 20"/>
+          <p:cNvSpPr txBox="1"/>
+          <p:nvPr/>
+        </p:nvSpPr>
+        <p:spPr>
+          <a:xfrm>
+            <a:off x="2606040" y="3364992"/>
+            <a:ext cx="1508760" cy="868680"/>
+          </a:xfrm>
+          <a:prstGeom prst="rect">
+            <a:avLst/>
+          </a:prstGeom>
+          <a:noFill/>
+        </p:spPr>
+        <p:txBody>
+          <a:bodyPr wrap="square">
+            <a:spAutoFit/>
+          </a:bodyPr>
+          <a:lstStyle/>
+          <a:p>
+            <a:pPr algn="l"/>
+            <a:r>
+              <a:rPr sz="1000" b="0" i="0">
+                <a:solidFill>
+                  <a:srgbClr val="88AAA8"/>
+                </a:solidFill>
+              </a:rPr>
+              <a:t>$45K/mo · zero paid ads
+Gen Z creator, Austin TX</a:t>
+            </a:r>
+          </a:p>
+        </p:txBody>
+      </p:sp>
+      <p:sp>
+        <p:nvSpPr>
+          <p:cNvPr id="22" name="Rounded Rectangle 21"/>
+          <p:cNvSpPr/>
+          <p:nvPr/>
+        </p:nvSpPr>
+        <p:spPr>
+          <a:xfrm>
+            <a:off x="4370831" y="2926080"/>
+            <a:ext cx="3749039" cy="1417320"/>
+          </a:xfrm>
+          <a:prstGeom prst="roundRect">
+            <a:avLst>
+              <a:gd name="adj" fmla="val 8000"/>
+            </a:avLst>
+          </a:prstGeom>
+          <a:solidFill>
+            <a:srgbClr val="103232"/>
+          </a:solidFill>
+          <a:ln>
+            <a:noFill/>
+          </a:ln>
+        </p:spPr>
+        <p:style>
+          <a:lnRef idx="1">
+            <a:schemeClr val="accent1"/>
+          </a:lnRef>
+          <a:fillRef idx="3">
+            <a:schemeClr val="accent1"/>
+          </a:fillRef>
+          <a:effectRef idx="2">
+            <a:schemeClr val="accent1"/>
+          </a:effectRef>
+          <a:fontRef idx="minor">
+            <a:schemeClr val="lt1"/>
+          </a:fontRef>
+        </p:style>
+        <p:txBody>
+          <a:bodyPr rtlCol="0" anchor="ctr"/>
+          <a:lstStyle/>
+          <a:p>
+            <a:pPr algn="ctr"/>
+          </a:p>
+        </p:txBody>
+      </p:sp>
+      <p:sp>
+        <p:nvSpPr>
+          <p:cNvPr id="23" name="Rectangle 22"/>
+          <p:cNvSpPr/>
+          <p:nvPr/>
+        </p:nvSpPr>
+        <p:spPr>
+          <a:xfrm>
+            <a:off x="4370831" y="2926080"/>
+            <a:ext cx="45720" cy="1417320"/>
+          </a:xfrm>
+          <a:prstGeom prst="rect">
+            <a:avLst/>
+          </a:prstGeom>
+          <a:solidFill>
+            <a:srgbClr val="4CC8C3"/>
+          </a:solidFill>
+          <a:ln>
+            <a:noFill/>
+          </a:ln>
+        </p:spPr>
+        <p:style>
+          <a:lnRef idx="1">
+            <a:schemeClr val="accent1"/>
+          </a:lnRef>
+          <a:fillRef idx="3">
+            <a:schemeClr val="accent1"/>
+          </a:fillRef>
+          <a:effectRef idx="2">
+            <a:schemeClr val="accent1"/>
+          </a:effectRef>
+          <a:fontRef idx="minor">
+            <a:schemeClr val="lt1"/>
+          </a:fontRef>
+        </p:style>
+        <p:txBody>
+          <a:bodyPr rtlCol="0" anchor="ctr"/>
+          <a:lstStyle/>
+          <a:p>
+            <a:pPr algn="ctr"/>
+          </a:p>
+        </p:txBody>
+      </p:sp>
+      <p:sp>
+        <p:nvSpPr>
+          <p:cNvPr id="24" name="TextBox 23"/>
+          <p:cNvSpPr txBox="1"/>
+          <p:nvPr/>
+        </p:nvSpPr>
+        <p:spPr>
+          <a:xfrm>
+            <a:off x="4480559" y="3017520"/>
+            <a:ext cx="594360" cy="640080"/>
+          </a:xfrm>
+          <a:prstGeom prst="rect">
+            <a:avLst/>
+          </a:prstGeom>
+          <a:noFill/>
+        </p:spPr>
+        <p:txBody>
+          <a:bodyPr wrap="square">
+            <a:spAutoFit/>
+          </a:bodyPr>
+          <a:lstStyle/>
+          <a:p>
+            <a:pPr algn="l"/>
+            <a:r>
+              <a:rPr sz="2800" b="0" i="0">
+                <a:solidFill>
+                  <a:srgbClr val="FFFFFF"/>
+                </a:solidFill>
+              </a:rPr>
+              <a:t>📮</a:t>
+            </a:r>
+          </a:p>
+        </p:txBody>
+      </p:sp>
+      <p:sp>
+        <p:nvSpPr>
           <p:cNvPr id="25" name="TextBox 24"/>
           <p:cNvSpPr txBox="1"/>
           <p:nvPr/>
         </p:nvSpPr>
         <p:spPr>
           <a:xfrm>
-            <a:off x="6400800" y="4389120"/>
-            <a:ext cx="822960" cy="731520"/>
-          </a:xfrm>
-          <a:prstGeom prst="rect">
-            <a:avLst/>
-          </a:prstGeom>
-          <a:noFill/>
-        </p:spPr>
-        <p:txBody>
-          <a:bodyPr wrap="square">
-            <a:spAutoFit/>
-          </a:bodyPr>
-          <a:lstStyle/>
-          <a:p>
-            <a:pPr algn="l"/>
-            <a:r>
-              <a:rPr sz="3600" b="0" i="0">
+            <a:off x="5148071" y="2999232"/>
+            <a:ext cx="1325880" cy="530352"/>
+          </a:xfrm>
+          <a:prstGeom prst="rect">
+            <a:avLst/>
+          </a:prstGeom>
+          <a:noFill/>
+        </p:spPr>
+        <p:txBody>
+          <a:bodyPr wrap="square">
+            <a:spAutoFit/>
+          </a:bodyPr>
+          <a:lstStyle/>
+          <a:p>
+            <a:pPr algn="l"/>
+            <a:r>
+              <a:rPr sz="3000" b="1" i="0">
+                <a:solidFill>
+                  <a:srgbClr val="4CC8C3"/>
+                </a:solidFill>
+              </a:rPr>
+              <a:t>806K+</a:t>
+            </a:r>
+          </a:p>
+        </p:txBody>
+      </p:sp>
+      <p:sp>
+        <p:nvSpPr>
+          <p:cNvPr id="26" name="TextBox 25"/>
+          <p:cNvSpPr txBox="1"/>
+          <p:nvPr/>
+        </p:nvSpPr>
+        <p:spPr>
+          <a:xfrm>
+            <a:off x="5148071" y="3493008"/>
+            <a:ext cx="1463040" cy="274320"/>
+          </a:xfrm>
+          <a:prstGeom prst="rect">
+            <a:avLst/>
+          </a:prstGeom>
+          <a:noFill/>
+        </p:spPr>
+        <p:txBody>
+          <a:bodyPr wrap="square">
+            <a:spAutoFit/>
+          </a:bodyPr>
+          <a:lstStyle/>
+          <a:p>
+            <a:pPr algn="l"/>
+            <a:r>
+              <a:rPr sz="1000" b="0" i="0">
+                <a:solidFill>
+                  <a:srgbClr val="A0E1DF"/>
+                </a:solidFill>
+              </a:rPr>
+              <a:t>members worldwide</a:t>
+            </a:r>
+          </a:p>
+        </p:txBody>
+      </p:sp>
+      <p:sp>
+        <p:nvSpPr>
+          <p:cNvPr id="27" name="TextBox 26"/>
+          <p:cNvSpPr txBox="1"/>
+          <p:nvPr/>
+        </p:nvSpPr>
+        <p:spPr>
+          <a:xfrm>
+            <a:off x="6519671" y="2999232"/>
+            <a:ext cx="1508760" cy="347472"/>
+          </a:xfrm>
+          <a:prstGeom prst="rect">
+            <a:avLst/>
+          </a:prstGeom>
+          <a:noFill/>
+        </p:spPr>
+        <p:txBody>
+          <a:bodyPr wrap="square">
+            <a:spAutoFit/>
+          </a:bodyPr>
+          <a:lstStyle/>
+          <a:p>
+            <a:pPr algn="l"/>
+            <a:r>
+              <a:rPr sz="1200" b="1" i="0">
                 <a:solidFill>
                   <a:srgbClr val="FFFFFF"/>
                 </a:solidFill>
               </a:rPr>
+              <a:t>Postcrossing</a:t>
+            </a:r>
+          </a:p>
+        </p:txBody>
+      </p:sp>
+      <p:sp>
+        <p:nvSpPr>
+          <p:cNvPr id="28" name="TextBox 27"/>
+          <p:cNvSpPr txBox="1"/>
+          <p:nvPr/>
+        </p:nvSpPr>
+        <p:spPr>
+          <a:xfrm>
+            <a:off x="6519671" y="3364992"/>
+            <a:ext cx="1508760" cy="868680"/>
+          </a:xfrm>
+          <a:prstGeom prst="rect">
+            <a:avLst/>
+          </a:prstGeom>
+          <a:noFill/>
+        </p:spPr>
+        <p:txBody>
+          <a:bodyPr wrap="square">
+            <a:spAutoFit/>
+          </a:bodyPr>
+          <a:lstStyle/>
+          <a:p>
+            <a:pPr algn="l"/>
+            <a:r>
+              <a:rPr sz="1000" b="0" i="0">
+                <a:solidFill>
+                  <a:srgbClr val="88AAA8"/>
+                </a:solidFill>
+              </a:rPr>
+              <a:t>87M+ postcards exchanged
+worldwide since 2005</a:t>
+            </a:r>
+          </a:p>
+        </p:txBody>
+      </p:sp>
+      <p:sp>
+        <p:nvSpPr>
+          <p:cNvPr id="29" name="Rounded Rectangle 28"/>
+          <p:cNvSpPr/>
+          <p:nvPr/>
+        </p:nvSpPr>
+        <p:spPr>
+          <a:xfrm>
+            <a:off x="8284462" y="2926080"/>
+            <a:ext cx="3749039" cy="1417320"/>
+          </a:xfrm>
+          <a:prstGeom prst="roundRect">
+            <a:avLst>
+              <a:gd name="adj" fmla="val 8000"/>
+            </a:avLst>
+          </a:prstGeom>
+          <a:solidFill>
+            <a:srgbClr val="103232"/>
+          </a:solidFill>
+          <a:ln>
+            <a:noFill/>
+          </a:ln>
+        </p:spPr>
+        <p:style>
+          <a:lnRef idx="1">
+            <a:schemeClr val="accent1"/>
+          </a:lnRef>
+          <a:fillRef idx="3">
+            <a:schemeClr val="accent1"/>
+          </a:fillRef>
+          <a:effectRef idx="2">
+            <a:schemeClr val="accent1"/>
+          </a:effectRef>
+          <a:fontRef idx="minor">
+            <a:schemeClr val="lt1"/>
+          </a:fontRef>
+        </p:style>
+        <p:txBody>
+          <a:bodyPr rtlCol="0" anchor="ctr"/>
+          <a:lstStyle/>
+          <a:p>
+            <a:pPr algn="ctr"/>
+          </a:p>
+        </p:txBody>
+      </p:sp>
+      <p:sp>
+        <p:nvSpPr>
+          <p:cNvPr id="30" name="Rectangle 29"/>
+          <p:cNvSpPr/>
+          <p:nvPr/>
+        </p:nvSpPr>
+        <p:spPr>
+          <a:xfrm>
+            <a:off x="8284462" y="2926080"/>
+            <a:ext cx="45720" cy="1417320"/>
+          </a:xfrm>
+          <a:prstGeom prst="rect">
+            <a:avLst/>
+          </a:prstGeom>
+          <a:solidFill>
+            <a:srgbClr val="4CC8C3"/>
+          </a:solidFill>
+          <a:ln>
+            <a:noFill/>
+          </a:ln>
+        </p:spPr>
+        <p:style>
+          <a:lnRef idx="1">
+            <a:schemeClr val="accent1"/>
+          </a:lnRef>
+          <a:fillRef idx="3">
+            <a:schemeClr val="accent1"/>
+          </a:fillRef>
+          <a:effectRef idx="2">
+            <a:schemeClr val="accent1"/>
+          </a:effectRef>
+          <a:fontRef idx="minor">
+            <a:schemeClr val="lt1"/>
+          </a:fontRef>
+        </p:style>
+        <p:txBody>
+          <a:bodyPr rtlCol="0" anchor="ctr"/>
+          <a:lstStyle/>
+          <a:p>
+            <a:pPr algn="ctr"/>
+          </a:p>
+        </p:txBody>
+      </p:sp>
+      <p:sp>
+        <p:nvSpPr>
+          <p:cNvPr id="31" name="TextBox 30"/>
+          <p:cNvSpPr txBox="1"/>
+          <p:nvPr/>
+        </p:nvSpPr>
+        <p:spPr>
+          <a:xfrm>
+            <a:off x="8394190" y="3017520"/>
+            <a:ext cx="594360" cy="640080"/>
+          </a:xfrm>
+          <a:prstGeom prst="rect">
+            <a:avLst/>
+          </a:prstGeom>
+          <a:noFill/>
+        </p:spPr>
+        <p:txBody>
+          <a:bodyPr wrap="square">
+            <a:spAutoFit/>
+          </a:bodyPr>
+          <a:lstStyle/>
+          <a:p>
+            <a:pPr algn="l"/>
+            <a:r>
+              <a:rPr sz="2800" b="0" i="0">
+                <a:solidFill>
+                  <a:srgbClr val="FFFFFF"/>
+                </a:solidFill>
+              </a:rPr>
+              <a:t>💌</a:t>
+            </a:r>
+          </a:p>
+        </p:txBody>
+      </p:sp>
+      <p:sp>
+        <p:nvSpPr>
+          <p:cNvPr id="32" name="TextBox 31"/>
+          <p:cNvSpPr txBox="1"/>
+          <p:nvPr/>
+        </p:nvSpPr>
+        <p:spPr>
+          <a:xfrm>
+            <a:off x="9061702" y="2999232"/>
+            <a:ext cx="1325880" cy="530352"/>
+          </a:xfrm>
+          <a:prstGeom prst="rect">
+            <a:avLst/>
+          </a:prstGeom>
+          <a:noFill/>
+        </p:spPr>
+        <p:txBody>
+          <a:bodyPr wrap="square">
+            <a:spAutoFit/>
+          </a:bodyPr>
+          <a:lstStyle/>
+          <a:p>
+            <a:pPr algn="l"/>
+            <a:r>
+              <a:rPr sz="3000" b="1" i="0">
+                <a:solidFill>
+                  <a:srgbClr val="4CC8C3"/>
+                </a:solidFill>
+              </a:rPr>
+              <a:t>1M+</a:t>
+            </a:r>
+          </a:p>
+        </p:txBody>
+      </p:sp>
+      <p:sp>
+        <p:nvSpPr>
+          <p:cNvPr id="33" name="TextBox 32"/>
+          <p:cNvSpPr txBox="1"/>
+          <p:nvPr/>
+        </p:nvSpPr>
+        <p:spPr>
+          <a:xfrm>
+            <a:off x="9061702" y="3493008"/>
+            <a:ext cx="1463040" cy="274320"/>
+          </a:xfrm>
+          <a:prstGeom prst="rect">
+            <a:avLst/>
+          </a:prstGeom>
+          <a:noFill/>
+        </p:spPr>
+        <p:txBody>
+          <a:bodyPr wrap="square">
+            <a:spAutoFit/>
+          </a:bodyPr>
+          <a:lstStyle/>
+          <a:p>
+            <a:pPr algn="l"/>
+            <a:r>
+              <a:rPr sz="1000" b="0" i="0">
+                <a:solidFill>
+                  <a:srgbClr val="A0E1DF"/>
+                </a:solidFill>
+              </a:rPr>
+              <a:t>letters delivered</a:t>
+            </a:r>
+          </a:p>
+        </p:txBody>
+      </p:sp>
+      <p:sp>
+        <p:nvSpPr>
+          <p:cNvPr id="34" name="TextBox 33"/>
+          <p:cNvSpPr txBox="1"/>
+          <p:nvPr/>
+        </p:nvSpPr>
+        <p:spPr>
+          <a:xfrm>
+            <a:off x="10433302" y="2999232"/>
+            <a:ext cx="1508760" cy="347472"/>
+          </a:xfrm>
+          <a:prstGeom prst="rect">
+            <a:avLst/>
+          </a:prstGeom>
+          <a:noFill/>
+        </p:spPr>
+        <p:txBody>
+          <a:bodyPr wrap="square">
+            <a:spAutoFit/>
+          </a:bodyPr>
+          <a:lstStyle/>
+          <a:p>
+            <a:pPr algn="l"/>
+            <a:r>
+              <a:rPr sz="1200" b="1" i="0">
+                <a:solidFill>
+                  <a:srgbClr val="FFFFFF"/>
+                </a:solidFill>
+              </a:rPr>
+              <a:t>Letters Against Isolation</a:t>
+            </a:r>
+          </a:p>
+        </p:txBody>
+      </p:sp>
+      <p:sp>
+        <p:nvSpPr>
+          <p:cNvPr id="35" name="TextBox 34"/>
+          <p:cNvSpPr txBox="1"/>
+          <p:nvPr/>
+        </p:nvSpPr>
+        <p:spPr>
+          <a:xfrm>
+            <a:off x="10433302" y="3364992"/>
+            <a:ext cx="1508760" cy="868680"/>
+          </a:xfrm>
+          <a:prstGeom prst="rect">
+            <a:avLst/>
+          </a:prstGeom>
+          <a:noFill/>
+        </p:spPr>
+        <p:txBody>
+          <a:bodyPr wrap="square">
+            <a:spAutoFit/>
+          </a:bodyPr>
+          <a:lstStyle/>
+          <a:p>
+            <a:pPr algn="l"/>
+            <a:r>
+              <a:rPr sz="1000" b="0" i="0">
+                <a:solidFill>
+                  <a:srgbClr val="88AAA8"/>
+                </a:solidFill>
+              </a:rPr>
+              <a:t>Launched during COVID
+complete strangers writing</a:t>
+            </a:r>
+          </a:p>
+        </p:txBody>
+      </p:sp>
+      <p:sp>
+        <p:nvSpPr>
+          <p:cNvPr id="36" name="Rounded Rectangle 35"/>
+          <p:cNvSpPr/>
+          <p:nvPr/>
+        </p:nvSpPr>
+        <p:spPr>
+          <a:xfrm>
+            <a:off x="457200" y="4471416"/>
+            <a:ext cx="3749039" cy="1417320"/>
+          </a:xfrm>
+          <a:prstGeom prst="roundRect">
+            <a:avLst>
+              <a:gd name="adj" fmla="val 8000"/>
+            </a:avLst>
+          </a:prstGeom>
+          <a:solidFill>
+            <a:srgbClr val="103232"/>
+          </a:solidFill>
+          <a:ln>
+            <a:noFill/>
+          </a:ln>
+        </p:spPr>
+        <p:style>
+          <a:lnRef idx="1">
+            <a:schemeClr val="accent1"/>
+          </a:lnRef>
+          <a:fillRef idx="3">
+            <a:schemeClr val="accent1"/>
+          </a:fillRef>
+          <a:effectRef idx="2">
+            <a:schemeClr val="accent1"/>
+          </a:effectRef>
+          <a:fontRef idx="minor">
+            <a:schemeClr val="lt1"/>
+          </a:fontRef>
+        </p:style>
+        <p:txBody>
+          <a:bodyPr rtlCol="0" anchor="ctr"/>
+          <a:lstStyle/>
+          <a:p>
+            <a:pPr algn="ctr"/>
+          </a:p>
+        </p:txBody>
+      </p:sp>
+      <p:sp>
+        <p:nvSpPr>
+          <p:cNvPr id="37" name="Rectangle 36"/>
+          <p:cNvSpPr/>
+          <p:nvPr/>
+        </p:nvSpPr>
+        <p:spPr>
+          <a:xfrm>
+            <a:off x="457200" y="4471416"/>
+            <a:ext cx="45720" cy="1417320"/>
+          </a:xfrm>
+          <a:prstGeom prst="rect">
+            <a:avLst/>
+          </a:prstGeom>
+          <a:solidFill>
+            <a:srgbClr val="28807D"/>
+          </a:solidFill>
+          <a:ln>
+            <a:noFill/>
+          </a:ln>
+        </p:spPr>
+        <p:style>
+          <a:lnRef idx="1">
+            <a:schemeClr val="accent1"/>
+          </a:lnRef>
+          <a:fillRef idx="3">
+            <a:schemeClr val="accent1"/>
+          </a:fillRef>
+          <a:effectRef idx="2">
+            <a:schemeClr val="accent1"/>
+          </a:effectRef>
+          <a:fontRef idx="minor">
+            <a:schemeClr val="lt1"/>
+          </a:fontRef>
+        </p:style>
+        <p:txBody>
+          <a:bodyPr rtlCol="0" anchor="ctr"/>
+          <a:lstStyle/>
+          <a:p>
+            <a:pPr algn="ctr"/>
+          </a:p>
+        </p:txBody>
+      </p:sp>
+      <p:sp>
+        <p:nvSpPr>
+          <p:cNvPr id="38" name="TextBox 37"/>
+          <p:cNvSpPr txBox="1"/>
+          <p:nvPr/>
+        </p:nvSpPr>
+        <p:spPr>
+          <a:xfrm>
+            <a:off x="566928" y="4562856"/>
+            <a:ext cx="594360" cy="640080"/>
+          </a:xfrm>
+          <a:prstGeom prst="rect">
+            <a:avLst/>
+          </a:prstGeom>
+          <a:noFill/>
+        </p:spPr>
+        <p:txBody>
+          <a:bodyPr wrap="square">
+            <a:spAutoFit/>
+          </a:bodyPr>
+          <a:lstStyle/>
+          <a:p>
+            <a:pPr algn="l"/>
+            <a:r>
+              <a:rPr sz="2800" b="0" i="0">
+                <a:solidFill>
+                  <a:srgbClr val="FFFFFF"/>
+                </a:solidFill>
+              </a:rPr>
+              <a:t>🤝</a:t>
+            </a:r>
+          </a:p>
+        </p:txBody>
+      </p:sp>
+      <p:sp>
+        <p:nvSpPr>
+          <p:cNvPr id="39" name="TextBox 38"/>
+          <p:cNvSpPr txBox="1"/>
+          <p:nvPr/>
+        </p:nvSpPr>
+        <p:spPr>
+          <a:xfrm>
+            <a:off x="1234440" y="4544568"/>
+            <a:ext cx="1325880" cy="530352"/>
+          </a:xfrm>
+          <a:prstGeom prst="rect">
+            <a:avLst/>
+          </a:prstGeom>
+          <a:noFill/>
+        </p:spPr>
+        <p:txBody>
+          <a:bodyPr wrap="square">
+            <a:spAutoFit/>
+          </a:bodyPr>
+          <a:lstStyle/>
+          <a:p>
+            <a:pPr algn="l"/>
+            <a:r>
+              <a:rPr sz="3000" b="1" i="0">
+                <a:solidFill>
+                  <a:srgbClr val="4CC8C3"/>
+                </a:solidFill>
+              </a:rPr>
+              <a:t>1M+</a:t>
+            </a:r>
+          </a:p>
+        </p:txBody>
+      </p:sp>
+      <p:sp>
+        <p:nvSpPr>
+          <p:cNvPr id="40" name="TextBox 39"/>
+          <p:cNvSpPr txBox="1"/>
+          <p:nvPr/>
+        </p:nvSpPr>
+        <p:spPr>
+          <a:xfrm>
+            <a:off x="1234440" y="5038344"/>
+            <a:ext cx="1463040" cy="274320"/>
+          </a:xfrm>
+          <a:prstGeom prst="rect">
+            <a:avLst/>
+          </a:prstGeom>
+          <a:noFill/>
+        </p:spPr>
+        <p:txBody>
+          <a:bodyPr wrap="square">
+            <a:spAutoFit/>
+          </a:bodyPr>
+          <a:lstStyle/>
+          <a:p>
+            <a:pPr algn="l"/>
+            <a:r>
+              <a:rPr sz="1000" b="0" i="0">
+                <a:solidFill>
+                  <a:srgbClr val="A0E1DF"/>
+                </a:solidFill>
+              </a:rPr>
+              <a:t>letters sent</a:t>
+            </a:r>
+          </a:p>
+        </p:txBody>
+      </p:sp>
+      <p:sp>
+        <p:nvSpPr>
+          <p:cNvPr id="41" name="TextBox 40"/>
+          <p:cNvSpPr txBox="1"/>
+          <p:nvPr/>
+        </p:nvSpPr>
+        <p:spPr>
+          <a:xfrm>
+            <a:off x="2606040" y="4544568"/>
+            <a:ext cx="1508760" cy="347472"/>
+          </a:xfrm>
+          <a:prstGeom prst="rect">
+            <a:avLst/>
+          </a:prstGeom>
+          <a:noFill/>
+        </p:spPr>
+        <p:txBody>
+          <a:bodyPr wrap="square">
+            <a:spAutoFit/>
+          </a:bodyPr>
+          <a:lstStyle/>
+          <a:p>
+            <a:pPr algn="l"/>
+            <a:r>
+              <a:rPr sz="1200" b="1" i="0">
+                <a:solidFill>
+                  <a:srgbClr val="FFFFFF"/>
+                </a:solidFill>
+              </a:rPr>
+              <a:t>Love For Our Elders</a:t>
+            </a:r>
+          </a:p>
+        </p:txBody>
+      </p:sp>
+      <p:sp>
+        <p:nvSpPr>
+          <p:cNvPr id="42" name="TextBox 41"/>
+          <p:cNvSpPr txBox="1"/>
+          <p:nvPr/>
+        </p:nvSpPr>
+        <p:spPr>
+          <a:xfrm>
+            <a:off x="2606040" y="4910328"/>
+            <a:ext cx="1508760" cy="868680"/>
+          </a:xfrm>
+          <a:prstGeom prst="rect">
+            <a:avLst/>
+          </a:prstGeom>
+          <a:noFill/>
+        </p:spPr>
+        <p:txBody>
+          <a:bodyPr wrap="square">
+            <a:spAutoFit/>
+          </a:bodyPr>
+          <a:lstStyle/>
+          <a:p>
+            <a:pPr algn="l"/>
+            <a:r>
+              <a:rPr sz="1000" b="0" i="0">
+                <a:solidFill>
+                  <a:srgbClr val="88AAA8"/>
+                </a:solidFill>
+              </a:rPr>
+              <a:t>100+ chapters · 70+
+mailboxes globally</a:t>
+            </a:r>
+          </a:p>
+        </p:txBody>
+      </p:sp>
+      <p:sp>
+        <p:nvSpPr>
+          <p:cNvPr id="43" name="Rounded Rectangle 42"/>
+          <p:cNvSpPr/>
+          <p:nvPr/>
+        </p:nvSpPr>
+        <p:spPr>
+          <a:xfrm>
+            <a:off x="4370831" y="4471416"/>
+            <a:ext cx="3749039" cy="1417320"/>
+          </a:xfrm>
+          <a:prstGeom prst="roundRect">
+            <a:avLst>
+              <a:gd name="adj" fmla="val 8000"/>
+            </a:avLst>
+          </a:prstGeom>
+          <a:solidFill>
+            <a:srgbClr val="103232"/>
+          </a:solidFill>
+          <a:ln>
+            <a:noFill/>
+          </a:ln>
+        </p:spPr>
+        <p:style>
+          <a:lnRef idx="1">
+            <a:schemeClr val="accent1"/>
+          </a:lnRef>
+          <a:fillRef idx="3">
+            <a:schemeClr val="accent1"/>
+          </a:fillRef>
+          <a:effectRef idx="2">
+            <a:schemeClr val="accent1"/>
+          </a:effectRef>
+          <a:fontRef idx="minor">
+            <a:schemeClr val="lt1"/>
+          </a:fontRef>
+        </p:style>
+        <p:txBody>
+          <a:bodyPr rtlCol="0" anchor="ctr"/>
+          <a:lstStyle/>
+          <a:p>
+            <a:pPr algn="ctr"/>
+          </a:p>
+        </p:txBody>
+      </p:sp>
+      <p:sp>
+        <p:nvSpPr>
+          <p:cNvPr id="44" name="Rectangle 43"/>
+          <p:cNvSpPr/>
+          <p:nvPr/>
+        </p:nvSpPr>
+        <p:spPr>
+          <a:xfrm>
+            <a:off x="4370831" y="4471416"/>
+            <a:ext cx="45720" cy="1417320"/>
+          </a:xfrm>
+          <a:prstGeom prst="rect">
+            <a:avLst/>
+          </a:prstGeom>
+          <a:solidFill>
+            <a:srgbClr val="28807D"/>
+          </a:solidFill>
+          <a:ln>
+            <a:noFill/>
+          </a:ln>
+        </p:spPr>
+        <p:style>
+          <a:lnRef idx="1">
+            <a:schemeClr val="accent1"/>
+          </a:lnRef>
+          <a:fillRef idx="3">
+            <a:schemeClr val="accent1"/>
+          </a:fillRef>
+          <a:effectRef idx="2">
+            <a:schemeClr val="accent1"/>
+          </a:effectRef>
+          <a:fontRef idx="minor">
+            <a:schemeClr val="lt1"/>
+          </a:fontRef>
+        </p:style>
+        <p:txBody>
+          <a:bodyPr rtlCol="0" anchor="ctr"/>
+          <a:lstStyle/>
+          <a:p>
+            <a:pPr algn="ctr"/>
+          </a:p>
+        </p:txBody>
+      </p:sp>
+      <p:sp>
+        <p:nvSpPr>
+          <p:cNvPr id="45" name="TextBox 44"/>
+          <p:cNvSpPr txBox="1"/>
+          <p:nvPr/>
+        </p:nvSpPr>
+        <p:spPr>
+          <a:xfrm>
+            <a:off x="4480559" y="4562856"/>
+            <a:ext cx="594360" cy="640080"/>
+          </a:xfrm>
+          <a:prstGeom prst="rect">
+            <a:avLst/>
+          </a:prstGeom>
+          <a:noFill/>
+        </p:spPr>
+        <p:txBody>
+          <a:bodyPr wrap="square">
+            <a:spAutoFit/>
+          </a:bodyPr>
+          <a:lstStyle/>
+          <a:p>
+            <a:pPr algn="l"/>
+            <a:r>
+              <a:rPr sz="2800" b="0" i="0">
+                <a:solidFill>
+                  <a:srgbClr val="FFFFFF"/>
+                </a:solidFill>
+              </a:rPr>
               <a:t>🌍</a:t>
             </a:r>
           </a:p>
@@ -11806,98 +12578,97 @@
       </p:sp>
       <p:sp>
         <p:nvSpPr>
-          <p:cNvPr id="26" name="TextBox 25"/>
-          <p:cNvSpPr txBox="1"/>
-          <p:nvPr/>
-        </p:nvSpPr>
-        <p:spPr>
-          <a:xfrm>
-            <a:off x="7223760" y="4361688"/>
-            <a:ext cx="2743200" cy="640080"/>
-          </a:xfrm>
-          <a:prstGeom prst="rect">
-            <a:avLst/>
-          </a:prstGeom>
-          <a:noFill/>
-        </p:spPr>
-        <p:txBody>
-          <a:bodyPr wrap="square">
-            <a:spAutoFit/>
-          </a:bodyPr>
-          <a:lstStyle/>
-          <a:p>
-            <a:pPr algn="l"/>
-            <a:r>
-              <a:rPr sz="3800" b="1" i="0">
+          <p:cNvPr id="46" name="TextBox 45"/>
+          <p:cNvSpPr txBox="1"/>
+          <p:nvPr/>
+        </p:nvSpPr>
+        <p:spPr>
+          <a:xfrm>
+            <a:off x="5148071" y="4544568"/>
+            <a:ext cx="1325880" cy="530352"/>
+          </a:xfrm>
+          <a:prstGeom prst="rect">
+            <a:avLst/>
+          </a:prstGeom>
+          <a:noFill/>
+        </p:spPr>
+        <p:txBody>
+          <a:bodyPr wrap="square">
+            <a:spAutoFit/>
+          </a:bodyPr>
+          <a:lstStyle/>
+          <a:p>
+            <a:pPr algn="l"/>
+            <a:r>
+              <a:rPr sz="3000" b="1" i="0">
                 <a:solidFill>
                   <a:srgbClr val="4CC8C3"/>
                 </a:solidFill>
               </a:rPr>
-              <a:t>All 50
-states</a:t>
-            </a:r>
-          </a:p>
-        </p:txBody>
-      </p:sp>
-      <p:sp>
-        <p:nvSpPr>
-          <p:cNvPr id="27" name="TextBox 26"/>
-          <p:cNvSpPr txBox="1"/>
-          <p:nvPr/>
-        </p:nvSpPr>
-        <p:spPr>
-          <a:xfrm>
-            <a:off x="7223760" y="4937760"/>
-            <a:ext cx="2743200" cy="320040"/>
-          </a:xfrm>
-          <a:prstGeom prst="rect">
-            <a:avLst/>
-          </a:prstGeom>
-          <a:noFill/>
-        </p:spPr>
-        <p:txBody>
-          <a:bodyPr wrap="square">
-            <a:spAutoFit/>
-          </a:bodyPr>
-          <a:lstStyle/>
-          <a:p>
-            <a:pPr algn="l"/>
-            <a:r>
-              <a:rPr sz="1400" b="0" i="0">
+              <a:t>All 50</a:t>
+            </a:r>
+          </a:p>
+        </p:txBody>
+      </p:sp>
+      <p:sp>
+        <p:nvSpPr>
+          <p:cNvPr id="47" name="TextBox 46"/>
+          <p:cNvSpPr txBox="1"/>
+          <p:nvPr/>
+        </p:nvSpPr>
+        <p:spPr>
+          <a:xfrm>
+            <a:off x="5148071" y="5038344"/>
+            <a:ext cx="1463040" cy="274320"/>
+          </a:xfrm>
+          <a:prstGeom prst="rect">
+            <a:avLst/>
+          </a:prstGeom>
+          <a:noFill/>
+        </p:spPr>
+        <p:txBody>
+          <a:bodyPr wrap="square">
+            <a:spAutoFit/>
+          </a:bodyPr>
+          <a:lstStyle/>
+          <a:p>
+            <a:pPr algn="l"/>
+            <a:r>
+              <a:rPr sz="1000" b="0" i="0">
                 <a:solidFill>
                   <a:srgbClr val="A0E1DF"/>
                 </a:solidFill>
               </a:rPr>
-              <a:t>+ 70+ countries</a:t>
-            </a:r>
-          </a:p>
-        </p:txBody>
-      </p:sp>
-      <p:sp>
-        <p:nvSpPr>
-          <p:cNvPr id="28" name="TextBox 27"/>
-          <p:cNvSpPr txBox="1"/>
-          <p:nvPr/>
-        </p:nvSpPr>
-        <p:spPr>
-          <a:xfrm>
-            <a:off x="7223760" y="5257800"/>
-            <a:ext cx="2560320" cy="457200"/>
-          </a:xfrm>
-          <a:prstGeom prst="rect">
-            <a:avLst/>
-          </a:prstGeom>
-          <a:noFill/>
-        </p:spPr>
-        <p:txBody>
-          <a:bodyPr wrap="square">
-            <a:spAutoFit/>
-          </a:bodyPr>
-          <a:lstStyle/>
-          <a:p>
-            <a:pPr algn="l"/>
-            <a:r>
-              <a:rPr sz="1300" b="1" i="0">
+              <a:t>states + 70+ countries</a:t>
+            </a:r>
+          </a:p>
+        </p:txBody>
+      </p:sp>
+      <p:sp>
+        <p:nvSpPr>
+          <p:cNvPr id="48" name="TextBox 47"/>
+          <p:cNvSpPr txBox="1"/>
+          <p:nvPr/>
+        </p:nvSpPr>
+        <p:spPr>
+          <a:xfrm>
+            <a:off x="6519671" y="4544568"/>
+            <a:ext cx="1508760" cy="347472"/>
+          </a:xfrm>
+          <a:prstGeom prst="rect">
+            <a:avLst/>
+          </a:prstGeom>
+          <a:noFill/>
+        </p:spPr>
+        <p:txBody>
+          <a:bodyPr wrap="square">
+            <a:spAutoFit/>
+          </a:bodyPr>
+          <a:lstStyle/>
+          <a:p>
+            <a:pPr algn="l"/>
+            <a:r>
+              <a:rPr sz="1200" b="1" i="0">
                 <a:solidFill>
                   <a:srgbClr val="FFFFFF"/>
                 </a:solidFill>
@@ -11909,68 +12680,327 @@
       </p:sp>
       <p:sp>
         <p:nvSpPr>
-          <p:cNvPr id="29" name="TextBox 28"/>
-          <p:cNvSpPr txBox="1"/>
-          <p:nvPr/>
-        </p:nvSpPr>
-        <p:spPr>
-          <a:xfrm>
-            <a:off x="9692640" y="4434840"/>
-            <a:ext cx="1737360" cy="1554480"/>
-          </a:xfrm>
-          <a:prstGeom prst="rect">
-            <a:avLst/>
-          </a:prstGeom>
-          <a:noFill/>
-        </p:spPr>
-        <p:txBody>
-          <a:bodyPr wrap="square">
-            <a:spAutoFit/>
-          </a:bodyPr>
-          <a:lstStyle/>
-          <a:p>
-            <a:pPr algn="l"/>
-            <a:r>
-              <a:rPr sz="1100" b="0" i="0">
+          <p:cNvPr id="49" name="TextBox 48"/>
+          <p:cNvSpPr txBox="1"/>
+          <p:nvPr/>
+        </p:nvSpPr>
+        <p:spPr>
+          <a:xfrm>
+            <a:off x="6519671" y="4910328"/>
+            <a:ext cx="1508760" cy="868680"/>
+          </a:xfrm>
+          <a:prstGeom prst="rect">
+            <a:avLst/>
+          </a:prstGeom>
+          <a:noFill/>
+        </p:spPr>
+        <p:txBody>
+          <a:bodyPr wrap="square">
+            <a:spAutoFit/>
+          </a:bodyPr>
+          <a:lstStyle/>
+          <a:p>
+            <a:pPr algn="l"/>
+            <a:r>
+              <a:rPr sz="1000" b="0" i="0">
                 <a:solidFill>
                   <a:srgbClr val="88AAA8"/>
                 </a:solidFill>
               </a:rPr>
-              <a:t>Active community
-sending encouragement</a:t>
-            </a:r>
-          </a:p>
-        </p:txBody>
-      </p:sp>
-      <p:sp>
-        <p:nvSpPr>
-          <p:cNvPr id="30" name="TextBox 29"/>
-          <p:cNvSpPr txBox="1"/>
-          <p:nvPr/>
-        </p:nvSpPr>
-        <p:spPr>
-          <a:xfrm>
-            <a:off x="457200" y="6446520"/>
-            <a:ext cx="11247120" cy="320040"/>
-          </a:xfrm>
-          <a:prstGeom prst="rect">
-            <a:avLst/>
-          </a:prstGeom>
-          <a:noFill/>
-        </p:spPr>
-        <p:txBody>
-          <a:bodyPr wrap="square">
-            <a:spAutoFit/>
-          </a:bodyPr>
-          <a:lstStyle/>
-          <a:p>
-            <a:pPr algn="l"/>
-            <a:r>
-              <a:rPr sz="1300" b="0" i="1">
+              <a:t>Active in every US state
+encouragement at scale</a:t>
+            </a:r>
+          </a:p>
+        </p:txBody>
+      </p:sp>
+      <p:sp>
+        <p:nvSpPr>
+          <p:cNvPr id="50" name="Rounded Rectangle 49"/>
+          <p:cNvSpPr/>
+          <p:nvPr/>
+        </p:nvSpPr>
+        <p:spPr>
+          <a:xfrm>
+            <a:off x="8284462" y="4471416"/>
+            <a:ext cx="3749039" cy="1417320"/>
+          </a:xfrm>
+          <a:prstGeom prst="roundRect">
+            <a:avLst>
+              <a:gd name="adj" fmla="val 8000"/>
+            </a:avLst>
+          </a:prstGeom>
+          <a:solidFill>
+            <a:srgbClr val="103232"/>
+          </a:solidFill>
+          <a:ln>
+            <a:noFill/>
+          </a:ln>
+        </p:spPr>
+        <p:style>
+          <a:lnRef idx="1">
+            <a:schemeClr val="accent1"/>
+          </a:lnRef>
+          <a:fillRef idx="3">
+            <a:schemeClr val="accent1"/>
+          </a:fillRef>
+          <a:effectRef idx="2">
+            <a:schemeClr val="accent1"/>
+          </a:effectRef>
+          <a:fontRef idx="minor">
+            <a:schemeClr val="lt1"/>
+          </a:fontRef>
+        </p:style>
+        <p:txBody>
+          <a:bodyPr rtlCol="0" anchor="ctr"/>
+          <a:lstStyle/>
+          <a:p>
+            <a:pPr algn="ctr"/>
+          </a:p>
+        </p:txBody>
+      </p:sp>
+      <p:sp>
+        <p:nvSpPr>
+          <p:cNvPr id="51" name="Rectangle 50"/>
+          <p:cNvSpPr/>
+          <p:nvPr/>
+        </p:nvSpPr>
+        <p:spPr>
+          <a:xfrm>
+            <a:off x="8284462" y="4471416"/>
+            <a:ext cx="45720" cy="1417320"/>
+          </a:xfrm>
+          <a:prstGeom prst="rect">
+            <a:avLst/>
+          </a:prstGeom>
+          <a:solidFill>
+            <a:srgbClr val="28807D"/>
+          </a:solidFill>
+          <a:ln>
+            <a:noFill/>
+          </a:ln>
+        </p:spPr>
+        <p:style>
+          <a:lnRef idx="1">
+            <a:schemeClr val="accent1"/>
+          </a:lnRef>
+          <a:fillRef idx="3">
+            <a:schemeClr val="accent1"/>
+          </a:fillRef>
+          <a:effectRef idx="2">
+            <a:schemeClr val="accent1"/>
+          </a:effectRef>
+          <a:fontRef idx="minor">
+            <a:schemeClr val="lt1"/>
+          </a:fontRef>
+        </p:style>
+        <p:txBody>
+          <a:bodyPr rtlCol="0" anchor="ctr"/>
+          <a:lstStyle/>
+          <a:p>
+            <a:pPr algn="ctr"/>
+          </a:p>
+        </p:txBody>
+      </p:sp>
+      <p:sp>
+        <p:nvSpPr>
+          <p:cNvPr id="52" name="TextBox 51"/>
+          <p:cNvSpPr txBox="1"/>
+          <p:nvPr/>
+        </p:nvSpPr>
+        <p:spPr>
+          <a:xfrm>
+            <a:off x="8394190" y="4562856"/>
+            <a:ext cx="594360" cy="640080"/>
+          </a:xfrm>
+          <a:prstGeom prst="rect">
+            <a:avLst/>
+          </a:prstGeom>
+          <a:noFill/>
+        </p:spPr>
+        <p:txBody>
+          <a:bodyPr wrap="square">
+            <a:spAutoFit/>
+          </a:bodyPr>
+          <a:lstStyle/>
+          <a:p>
+            <a:pPr algn="l"/>
+            <a:r>
+              <a:rPr sz="2800" b="0" i="0">
+                <a:solidFill>
+                  <a:srgbClr val="FFFFFF"/>
+                </a:solidFill>
+              </a:rPr>
+              <a:t>📖</a:t>
+            </a:r>
+          </a:p>
+        </p:txBody>
+      </p:sp>
+      <p:sp>
+        <p:nvSpPr>
+          <p:cNvPr id="53" name="TextBox 52"/>
+          <p:cNvSpPr txBox="1"/>
+          <p:nvPr/>
+        </p:nvSpPr>
+        <p:spPr>
+          <a:xfrm>
+            <a:off x="9061702" y="4544568"/>
+            <a:ext cx="1325880" cy="530352"/>
+          </a:xfrm>
+          <a:prstGeom prst="rect">
+            <a:avLst/>
+          </a:prstGeom>
+          <a:noFill/>
+        </p:spPr>
+        <p:txBody>
+          <a:bodyPr wrap="square">
+            <a:spAutoFit/>
+          </a:bodyPr>
+          <a:lstStyle/>
+          <a:p>
+            <a:pPr algn="l"/>
+            <a:r>
+              <a:rPr sz="3000" b="1" i="0">
+                <a:solidFill>
+                  <a:srgbClr val="4CC8C3"/>
+                </a:solidFill>
+              </a:rPr>
+              <a:t>1,600</a:t>
+            </a:r>
+          </a:p>
+        </p:txBody>
+      </p:sp>
+      <p:sp>
+        <p:nvSpPr>
+          <p:cNvPr id="54" name="TextBox 53"/>
+          <p:cNvSpPr txBox="1"/>
+          <p:nvPr/>
+        </p:nvSpPr>
+        <p:spPr>
+          <a:xfrm>
+            <a:off x="9061702" y="5038344"/>
+            <a:ext cx="1463040" cy="274320"/>
+          </a:xfrm>
+          <a:prstGeom prst="rect">
+            <a:avLst/>
+          </a:prstGeom>
+          <a:noFill/>
+        </p:spPr>
+        <p:txBody>
+          <a:bodyPr wrap="square">
+            <a:spAutoFit/>
+          </a:bodyPr>
+          <a:lstStyle/>
+          <a:p>
+            <a:pPr algn="l"/>
+            <a:r>
+              <a:rPr sz="1000" b="0" i="0">
                 <a:solidFill>
                   <a:srgbClr val="A0E1DF"/>
                 </a:solidFill>
               </a:rPr>
+              <a:t>members in weeks</a:t>
+            </a:r>
+          </a:p>
+        </p:txBody>
+      </p:sp>
+      <p:sp>
+        <p:nvSpPr>
+          <p:cNvPr id="55" name="TextBox 54"/>
+          <p:cNvSpPr txBox="1"/>
+          <p:nvPr/>
+        </p:nvSpPr>
+        <p:spPr>
+          <a:xfrm>
+            <a:off x="10433302" y="4544568"/>
+            <a:ext cx="1508760" cy="347472"/>
+          </a:xfrm>
+          <a:prstGeom prst="rect">
+            <a:avLst/>
+          </a:prstGeom>
+          <a:noFill/>
+        </p:spPr>
+        <p:txBody>
+          <a:bodyPr wrap="square">
+            <a:spAutoFit/>
+          </a:bodyPr>
+          <a:lstStyle/>
+          <a:p>
+            <a:pPr algn="l"/>
+            <a:r>
+              <a:rPr sz="1200" b="1" i="0">
+                <a:solidFill>
+                  <a:srgbClr val="FFFFFF"/>
+                </a:solidFill>
+              </a:rPr>
+              <a:t>Analog Life Snail Society</a:t>
+            </a:r>
+          </a:p>
+        </p:txBody>
+      </p:sp>
+      <p:sp>
+        <p:nvSpPr>
+          <p:cNvPr id="56" name="TextBox 55"/>
+          <p:cNvSpPr txBox="1"/>
+          <p:nvPr/>
+        </p:nvSpPr>
+        <p:spPr>
+          <a:xfrm>
+            <a:off x="10433302" y="4910328"/>
+            <a:ext cx="1508760" cy="868680"/>
+          </a:xfrm>
+          <a:prstGeom prst="rect">
+            <a:avLst/>
+          </a:prstGeom>
+          <a:noFill/>
+        </p:spPr>
+        <p:txBody>
+          <a:bodyPr wrap="square">
+            <a:spAutoFit/>
+          </a:bodyPr>
+          <a:lstStyle/>
+          <a:p>
+            <a:pPr algn="l"/>
+            <a:r>
+              <a:rPr sz="1000" b="0" i="0">
+                <a:solidFill>
+                  <a:srgbClr val="88AAA8"/>
+                </a:solidFill>
+              </a:rPr>
+              <a:t>Grew from 25 to 1,600
+members in one month</a:t>
+            </a:r>
+          </a:p>
+        </p:txBody>
+      </p:sp>
+      <p:sp>
+        <p:nvSpPr>
+          <p:cNvPr id="57" name="TextBox 56"/>
+          <p:cNvSpPr txBox="1"/>
+          <p:nvPr/>
+        </p:nvSpPr>
+        <p:spPr>
+          <a:xfrm>
+            <a:off x="457200" y="6492240"/>
+            <a:ext cx="11247120" cy="292608"/>
+          </a:xfrm>
+          <a:prstGeom prst="rect">
+            <a:avLst/>
+          </a:prstGeom>
+          <a:noFill/>
+        </p:spPr>
+        <p:txBody>
+          <a:bodyPr wrap="square">
+            <a:spAutoFit/>
+          </a:bodyPr>
+          <a:lstStyle/>
+          <a:p>
+            <a:pPr algn="l"/>
+            <a:r>
+              <a:rPr sz="1200" b="0" i="1">
+                <a:solidFill>
+                  <a:srgbClr val="A0E1DF"/>
+                </a:solidFill>
+              </a:rPr>
               <a:t>✦  Real mail isn't nostalgic — it's powerful. Kids just haven't had it built for them.</a:t>
             </a:r>
           </a:p>
@@ -11978,7 +13008,7 @@
       </p:sp>
       <p:sp>
         <p:nvSpPr>
-          <p:cNvPr id="31" name="TextBox 30"/>
+          <p:cNvPr id="58" name="TextBox 57"/>
           <p:cNvSpPr txBox="1"/>
           <p:nvPr/>
         </p:nvSpPr>

</xml_diff>

<commit_message>
Rebuild slide 4 with named creator proof points from Business Insider / CNBC coverage
Adds: The Tiny Post (Hannah, $45K/mo, 5K subs), The Architecture Club
(Trinity Shiroma, $18,300/mo, 2,700 subs), Little Kitchen of Bo (4K
subs, first drop), The Cloud Report (crossing guard, $14K/mo, 3,600
waitlist). Top stat strip: 84% Americans going analog, 150K+ TikTok
posts, ~50% Gen Z mails monthly, 63% cutting screen time.

https://claude.ai/code/session_01CLjwbj5nXTNesYSPGcg1qG
</commit_message>
<xml_diff>
--- a/K3C_Pitch_Deck.pptx
+++ b/K3C_Pitch_Deck.pptx
@@ -11007,8 +11007,8 @@
         </p:nvSpPr>
         <p:spPr>
           <a:xfrm>
-            <a:off x="457200" y="868680"/>
-            <a:ext cx="9144000" cy="685800"/>
+            <a:off x="457200" y="841248"/>
+            <a:ext cx="9601200" cy="658368"/>
           </a:xfrm>
           <a:prstGeom prst="rect">
             <a:avLst/>
@@ -11028,7 +11028,7 @@
                   <a:srgbClr val="FFFFFF"/>
                 </a:solidFill>
               </a:rPr>
-              <a:t>The mail revival is already happening.</a:t>
+              <a:t>The mail revival is already a business.</a:t>
             </a:r>
           </a:p>
         </p:txBody>
@@ -11041,8 +11041,8 @@
         </p:nvSpPr>
         <p:spPr>
           <a:xfrm>
-            <a:off x="457200" y="1536192"/>
-            <a:ext cx="5029200" cy="45720"/>
+            <a:off x="457200" y="1481328"/>
+            <a:ext cx="5943600" cy="45720"/>
           </a:xfrm>
           <a:prstGeom prst="rect">
             <a:avLst/>
@@ -11084,350 +11084,8 @@
         </p:nvSpPr>
         <p:spPr>
           <a:xfrm>
-            <a:off x="457200" y="1664208"/>
-            <a:ext cx="3657600" cy="1078992"/>
-          </a:xfrm>
-          <a:prstGeom prst="roundRect">
-            <a:avLst>
-              <a:gd name="adj" fmla="val 8000"/>
-            </a:avLst>
-          </a:prstGeom>
-          <a:solidFill>
-            <a:srgbClr val="28807D"/>
-          </a:solidFill>
-          <a:ln>
-            <a:noFill/>
-          </a:ln>
-        </p:spPr>
-        <p:style>
-          <a:lnRef idx="1">
-            <a:schemeClr val="accent1"/>
-          </a:lnRef>
-          <a:fillRef idx="3">
-            <a:schemeClr val="accent1"/>
-          </a:fillRef>
-          <a:effectRef idx="2">
-            <a:schemeClr val="accent1"/>
-          </a:effectRef>
-          <a:fontRef idx="minor">
-            <a:schemeClr val="lt1"/>
-          </a:fontRef>
-        </p:style>
-        <p:txBody>
-          <a:bodyPr rtlCol="0" anchor="ctr"/>
-          <a:lstStyle/>
-          <a:p>
-            <a:pPr algn="ctr"/>
-          </a:p>
-        </p:txBody>
-      </p:sp>
-      <p:sp>
-        <p:nvSpPr>
-          <p:cNvPr id="7" name="TextBox 6"/>
-          <p:cNvSpPr txBox="1"/>
-          <p:nvPr/>
-        </p:nvSpPr>
-        <p:spPr>
-          <a:xfrm>
-            <a:off x="621792" y="1737360"/>
-            <a:ext cx="1463040" cy="658368"/>
-          </a:xfrm>
-          <a:prstGeom prst="rect">
-            <a:avLst/>
-          </a:prstGeom>
-          <a:noFill/>
-        </p:spPr>
-        <p:txBody>
-          <a:bodyPr wrap="square">
-            <a:spAutoFit/>
-          </a:bodyPr>
-          <a:lstStyle/>
-          <a:p>
-            <a:pPr algn="l"/>
-            <a:r>
-              <a:rPr sz="3600" b="1" i="0">
-                <a:solidFill>
-                  <a:srgbClr val="4CC8C3"/>
-                </a:solidFill>
-              </a:rPr>
-              <a:t>150K+</a:t>
-            </a:r>
-          </a:p>
-        </p:txBody>
-      </p:sp>
-      <p:sp>
-        <p:nvSpPr>
-          <p:cNvPr id="8" name="TextBox 7"/>
-          <p:cNvSpPr txBox="1"/>
-          <p:nvPr/>
-        </p:nvSpPr>
-        <p:spPr>
-          <a:xfrm>
-            <a:off x="2148840" y="1792224"/>
-            <a:ext cx="1828800" cy="822960"/>
-          </a:xfrm>
-          <a:prstGeom prst="rect">
-            <a:avLst/>
-          </a:prstGeom>
-          <a:noFill/>
-        </p:spPr>
-        <p:txBody>
-          <a:bodyPr wrap="square">
-            <a:spAutoFit/>
-          </a:bodyPr>
-          <a:lstStyle/>
-          <a:p>
-            <a:pPr algn="l"/>
-            <a:r>
-              <a:rPr sz="1200" b="0" i="0">
-                <a:solidFill>
-                  <a:srgbClr val="E8F4F3"/>
-                </a:solidFill>
-              </a:rPr>
-              <a:t>TikTok posts
-tagged #snailmail</a:t>
-            </a:r>
-          </a:p>
-        </p:txBody>
-      </p:sp>
-      <p:sp>
-        <p:nvSpPr>
-          <p:cNvPr id="9" name="Rounded Rectangle 8"/>
-          <p:cNvSpPr/>
-          <p:nvPr/>
-        </p:nvSpPr>
-        <p:spPr>
-          <a:xfrm>
-            <a:off x="4343400" y="1664208"/>
-            <a:ext cx="3657600" cy="1078992"/>
-          </a:xfrm>
-          <a:prstGeom prst="roundRect">
-            <a:avLst>
-              <a:gd name="adj" fmla="val 8000"/>
-            </a:avLst>
-          </a:prstGeom>
-          <a:solidFill>
-            <a:srgbClr val="28807D"/>
-          </a:solidFill>
-          <a:ln>
-            <a:noFill/>
-          </a:ln>
-        </p:spPr>
-        <p:style>
-          <a:lnRef idx="1">
-            <a:schemeClr val="accent1"/>
-          </a:lnRef>
-          <a:fillRef idx="3">
-            <a:schemeClr val="accent1"/>
-          </a:fillRef>
-          <a:effectRef idx="2">
-            <a:schemeClr val="accent1"/>
-          </a:effectRef>
-          <a:fontRef idx="minor">
-            <a:schemeClr val="lt1"/>
-          </a:fontRef>
-        </p:style>
-        <p:txBody>
-          <a:bodyPr rtlCol="0" anchor="ctr"/>
-          <a:lstStyle/>
-          <a:p>
-            <a:pPr algn="ctr"/>
-          </a:p>
-        </p:txBody>
-      </p:sp>
-      <p:sp>
-        <p:nvSpPr>
-          <p:cNvPr id="10" name="TextBox 9"/>
-          <p:cNvSpPr txBox="1"/>
-          <p:nvPr/>
-        </p:nvSpPr>
-        <p:spPr>
-          <a:xfrm>
-            <a:off x="4507992" y="1737360"/>
-            <a:ext cx="1463040" cy="658368"/>
-          </a:xfrm>
-          <a:prstGeom prst="rect">
-            <a:avLst/>
-          </a:prstGeom>
-          <a:noFill/>
-        </p:spPr>
-        <p:txBody>
-          <a:bodyPr wrap="square">
-            <a:spAutoFit/>
-          </a:bodyPr>
-          <a:lstStyle/>
-          <a:p>
-            <a:pPr algn="l"/>
-            <a:r>
-              <a:rPr sz="3600" b="1" i="0">
-                <a:solidFill>
-                  <a:srgbClr val="4CC8C3"/>
-                </a:solidFill>
-              </a:rPr>
-              <a:t>63%</a:t>
-            </a:r>
-          </a:p>
-        </p:txBody>
-      </p:sp>
-      <p:sp>
-        <p:nvSpPr>
-          <p:cNvPr id="11" name="TextBox 10"/>
-          <p:cNvSpPr txBox="1"/>
-          <p:nvPr/>
-        </p:nvSpPr>
-        <p:spPr>
-          <a:xfrm>
-            <a:off x="6035040" y="1792224"/>
-            <a:ext cx="1828800" cy="822960"/>
-          </a:xfrm>
-          <a:prstGeom prst="rect">
-            <a:avLst/>
-          </a:prstGeom>
-          <a:noFill/>
-        </p:spPr>
-        <p:txBody>
-          <a:bodyPr wrap="square">
-            <a:spAutoFit/>
-          </a:bodyPr>
-          <a:lstStyle/>
-          <a:p>
-            <a:pPr algn="l"/>
-            <a:r>
-              <a:rPr sz="1200" b="0" i="0">
-                <a:solidFill>
-                  <a:srgbClr val="E8F4F3"/>
-                </a:solidFill>
-              </a:rPr>
-              <a:t>of Gen Z actively
-disconnecting digitally</a:t>
-            </a:r>
-          </a:p>
-        </p:txBody>
-      </p:sp>
-      <p:sp>
-        <p:nvSpPr>
-          <p:cNvPr id="12" name="Rounded Rectangle 11"/>
-          <p:cNvSpPr/>
-          <p:nvPr/>
-        </p:nvSpPr>
-        <p:spPr>
-          <a:xfrm>
-            <a:off x="8229600" y="1664208"/>
-            <a:ext cx="3657600" cy="1078992"/>
-          </a:xfrm>
-          <a:prstGeom prst="roundRect">
-            <a:avLst>
-              <a:gd name="adj" fmla="val 8000"/>
-            </a:avLst>
-          </a:prstGeom>
-          <a:solidFill>
-            <a:srgbClr val="28807D"/>
-          </a:solidFill>
-          <a:ln>
-            <a:noFill/>
-          </a:ln>
-        </p:spPr>
-        <p:style>
-          <a:lnRef idx="1">
-            <a:schemeClr val="accent1"/>
-          </a:lnRef>
-          <a:fillRef idx="3">
-            <a:schemeClr val="accent1"/>
-          </a:fillRef>
-          <a:effectRef idx="2">
-            <a:schemeClr val="accent1"/>
-          </a:effectRef>
-          <a:fontRef idx="minor">
-            <a:schemeClr val="lt1"/>
-          </a:fontRef>
-        </p:style>
-        <p:txBody>
-          <a:bodyPr rtlCol="0" anchor="ctr"/>
-          <a:lstStyle/>
-          <a:p>
-            <a:pPr algn="ctr"/>
-          </a:p>
-        </p:txBody>
-      </p:sp>
-      <p:sp>
-        <p:nvSpPr>
-          <p:cNvPr id="13" name="TextBox 12"/>
-          <p:cNvSpPr txBox="1"/>
-          <p:nvPr/>
-        </p:nvSpPr>
-        <p:spPr>
-          <a:xfrm>
-            <a:off x="8394192" y="1737360"/>
-            <a:ext cx="1463040" cy="658368"/>
-          </a:xfrm>
-          <a:prstGeom prst="rect">
-            <a:avLst/>
-          </a:prstGeom>
-          <a:noFill/>
-        </p:spPr>
-        <p:txBody>
-          <a:bodyPr wrap="square">
-            <a:spAutoFit/>
-          </a:bodyPr>
-          <a:lstStyle/>
-          <a:p>
-            <a:pPr algn="l"/>
-            <a:r>
-              <a:rPr sz="3600" b="1" i="0">
-                <a:solidFill>
-                  <a:srgbClr val="4CC8C3"/>
-                </a:solidFill>
-              </a:rPr>
-              <a:t>$45K</a:t>
-            </a:r>
-          </a:p>
-        </p:txBody>
-      </p:sp>
-      <p:sp>
-        <p:nvSpPr>
-          <p:cNvPr id="14" name="TextBox 13"/>
-          <p:cNvSpPr txBox="1"/>
-          <p:nvPr/>
-        </p:nvSpPr>
-        <p:spPr>
-          <a:xfrm>
-            <a:off x="9921240" y="1792224"/>
-            <a:ext cx="1828800" cy="822960"/>
-          </a:xfrm>
-          <a:prstGeom prst="rect">
-            <a:avLst/>
-          </a:prstGeom>
-          <a:noFill/>
-        </p:spPr>
-        <p:txBody>
-          <a:bodyPr wrap="square">
-            <a:spAutoFit/>
-          </a:bodyPr>
-          <a:lstStyle/>
-          <a:p>
-            <a:pPr algn="l"/>
-            <a:r>
-              <a:rPr sz="1200" b="0" i="0">
-                <a:solidFill>
-                  <a:srgbClr val="E8F4F3"/>
-                </a:solidFill>
-              </a:rPr>
-              <a:t>revenue/mo — one
-snail mail club, zero paid ads</a:t>
-            </a:r>
-          </a:p>
-        </p:txBody>
-      </p:sp>
-      <p:sp>
-        <p:nvSpPr>
-          <p:cNvPr id="15" name="Rounded Rectangle 14"/>
-          <p:cNvSpPr/>
-          <p:nvPr/>
-        </p:nvSpPr>
-        <p:spPr>
-          <a:xfrm>
-            <a:off x="457200" y="2926080"/>
-            <a:ext cx="3749039" cy="1417320"/>
+            <a:off x="457200" y="1600200"/>
+            <a:ext cx="2788920" cy="1188720"/>
           </a:xfrm>
           <a:prstGeom prst="roundRect">
             <a:avLst>
@@ -11465,14 +11123,14 @@
       </p:sp>
       <p:sp>
         <p:nvSpPr>
-          <p:cNvPr id="16" name="Rectangle 15"/>
+          <p:cNvPr id="7" name="Rectangle 6"/>
           <p:cNvSpPr/>
           <p:nvPr/>
         </p:nvSpPr>
         <p:spPr>
           <a:xfrm>
-            <a:off x="457200" y="2926080"/>
-            <a:ext cx="45720" cy="1417320"/>
+            <a:off x="457200" y="1600200"/>
+            <a:ext cx="2788920" cy="45720"/>
           </a:xfrm>
           <a:prstGeom prst="rect">
             <a:avLst/>
@@ -11508,48 +11166,14 @@
       </p:sp>
       <p:sp>
         <p:nvSpPr>
-          <p:cNvPr id="17" name="TextBox 16"/>
-          <p:cNvSpPr txBox="1"/>
-          <p:nvPr/>
-        </p:nvSpPr>
-        <p:spPr>
-          <a:xfrm>
-            <a:off x="566928" y="3017520"/>
-            <a:ext cx="594360" cy="640080"/>
-          </a:xfrm>
-          <a:prstGeom prst="rect">
-            <a:avLst/>
-          </a:prstGeom>
-          <a:noFill/>
-        </p:spPr>
-        <p:txBody>
-          <a:bodyPr wrap="square">
-            <a:spAutoFit/>
-          </a:bodyPr>
-          <a:lstStyle/>
-          <a:p>
-            <a:pPr algn="l"/>
-            <a:r>
-              <a:rPr sz="2800" b="0" i="0">
-                <a:solidFill>
-                  <a:srgbClr val="FFFFFF"/>
-                </a:solidFill>
-              </a:rPr>
-              <a:t>✉️</a:t>
-            </a:r>
-          </a:p>
-        </p:txBody>
-      </p:sp>
-      <p:sp>
-        <p:nvSpPr>
-          <p:cNvPr id="18" name="TextBox 17"/>
-          <p:cNvSpPr txBox="1"/>
-          <p:nvPr/>
-        </p:nvSpPr>
-        <p:spPr>
-          <a:xfrm>
-            <a:off x="1234440" y="2999232"/>
-            <a:ext cx="1325880" cy="530352"/>
+          <p:cNvPr id="8" name="TextBox 7"/>
+          <p:cNvSpPr txBox="1"/>
+          <p:nvPr/>
+        </p:nvSpPr>
+        <p:spPr>
+          <a:xfrm>
+            <a:off x="594360" y="1682496"/>
+            <a:ext cx="1097280" cy="594360"/>
           </a:xfrm>
           <a:prstGeom prst="rect">
             <a:avLst/>
@@ -11569,21 +11193,21 @@
                   <a:srgbClr val="4CC8C3"/>
                 </a:solidFill>
               </a:rPr>
-              <a:t>5,000</a:t>
-            </a:r>
-          </a:p>
-        </p:txBody>
-      </p:sp>
-      <p:sp>
-        <p:nvSpPr>
-          <p:cNvPr id="19" name="TextBox 18"/>
-          <p:cNvSpPr txBox="1"/>
-          <p:nvPr/>
-        </p:nvSpPr>
-        <p:spPr>
-          <a:xfrm>
-            <a:off x="1234440" y="3493008"/>
-            <a:ext cx="1463040" cy="274320"/>
+              <a:t>84%</a:t>
+            </a:r>
+          </a:p>
+        </p:txBody>
+      </p:sp>
+      <p:sp>
+        <p:nvSpPr>
+          <p:cNvPr id="9" name="TextBox 8"/>
+          <p:cNvSpPr txBox="1"/>
+          <p:nvPr/>
+        </p:nvSpPr>
+        <p:spPr>
+          <a:xfrm>
+            <a:off x="1691640" y="1664208"/>
+            <a:ext cx="1463040" cy="1005840"/>
           </a:xfrm>
           <a:prstGeom prst="rect">
             <a:avLst/>
@@ -11600,93 +11224,26 @@
             <a:r>
               <a:rPr sz="1000" b="0" i="0">
                 <a:solidFill>
-                  <a:srgbClr val="A0E1DF"/>
-                </a:solidFill>
-              </a:rPr>
-              <a:t>paying subscribers</a:t>
-            </a:r>
-          </a:p>
-        </p:txBody>
-      </p:sp>
-      <p:sp>
-        <p:nvSpPr>
-          <p:cNvPr id="20" name="TextBox 19"/>
-          <p:cNvSpPr txBox="1"/>
-          <p:nvPr/>
-        </p:nvSpPr>
-        <p:spPr>
-          <a:xfrm>
-            <a:off x="2606040" y="2999232"/>
-            <a:ext cx="1508760" cy="347472"/>
-          </a:xfrm>
-          <a:prstGeom prst="rect">
-            <a:avLst/>
-          </a:prstGeom>
-          <a:noFill/>
-        </p:spPr>
-        <p:txBody>
-          <a:bodyPr wrap="square">
-            <a:spAutoFit/>
-          </a:bodyPr>
-          <a:lstStyle/>
-          <a:p>
-            <a:pPr algn="l"/>
-            <a:r>
-              <a:rPr sz="1200" b="1" i="0">
-                <a:solidFill>
-                  <a:srgbClr val="FFFFFF"/>
-                </a:solidFill>
-              </a:rPr>
-              <a:t>The Tiny Post</a:t>
-            </a:r>
-          </a:p>
-        </p:txBody>
-      </p:sp>
-      <p:sp>
-        <p:nvSpPr>
-          <p:cNvPr id="21" name="TextBox 20"/>
-          <p:cNvSpPr txBox="1"/>
-          <p:nvPr/>
-        </p:nvSpPr>
-        <p:spPr>
-          <a:xfrm>
-            <a:off x="2606040" y="3364992"/>
-            <a:ext cx="1508760" cy="868680"/>
-          </a:xfrm>
-          <a:prstGeom prst="rect">
-            <a:avLst/>
-          </a:prstGeom>
-          <a:noFill/>
-        </p:spPr>
-        <p:txBody>
-          <a:bodyPr wrap="square">
-            <a:spAutoFit/>
-          </a:bodyPr>
-          <a:lstStyle/>
-          <a:p>
-            <a:pPr algn="l"/>
-            <a:r>
-              <a:rPr sz="1000" b="0" i="0">
-                <a:solidFill>
-                  <a:srgbClr val="88AAA8"/>
-                </a:solidFill>
-              </a:rPr>
-              <a:t>$45K/mo · zero paid ads
-Gen Z creator, Austin TX</a:t>
-            </a:r>
-          </a:p>
-        </p:txBody>
-      </p:sp>
-      <p:sp>
-        <p:nvSpPr>
-          <p:cNvPr id="22" name="Rounded Rectangle 21"/>
+                  <a:srgbClr val="E8F4F3"/>
+                </a:solidFill>
+              </a:rPr>
+              <a:t>of Americans now
+incorporating analog
+lifestyle choices</a:t>
+            </a:r>
+          </a:p>
+        </p:txBody>
+      </p:sp>
+      <p:sp>
+        <p:nvSpPr>
+          <p:cNvPr id="10" name="Rounded Rectangle 9"/>
           <p:cNvSpPr/>
           <p:nvPr/>
         </p:nvSpPr>
         <p:spPr>
           <a:xfrm>
-            <a:off x="4370831" y="2926080"/>
-            <a:ext cx="3749039" cy="1417320"/>
+            <a:off x="3355848" y="1600200"/>
+            <a:ext cx="2788920" cy="1188720"/>
           </a:xfrm>
           <a:prstGeom prst="roundRect">
             <a:avLst>
@@ -11724,14 +11281,14 @@
       </p:sp>
       <p:sp>
         <p:nvSpPr>
-          <p:cNvPr id="23" name="Rectangle 22"/>
+          <p:cNvPr id="11" name="Rectangle 10"/>
           <p:cNvSpPr/>
           <p:nvPr/>
         </p:nvSpPr>
         <p:spPr>
           <a:xfrm>
-            <a:off x="4370831" y="2926080"/>
-            <a:ext cx="45720" cy="1417320"/>
+            <a:off x="3355848" y="1600200"/>
+            <a:ext cx="2788920" cy="45720"/>
           </a:xfrm>
           <a:prstGeom prst="rect">
             <a:avLst/>
@@ -11767,48 +11324,14 @@
       </p:sp>
       <p:sp>
         <p:nvSpPr>
-          <p:cNvPr id="24" name="TextBox 23"/>
-          <p:cNvSpPr txBox="1"/>
-          <p:nvPr/>
-        </p:nvSpPr>
-        <p:spPr>
-          <a:xfrm>
-            <a:off x="4480559" y="3017520"/>
-            <a:ext cx="594360" cy="640080"/>
-          </a:xfrm>
-          <a:prstGeom prst="rect">
-            <a:avLst/>
-          </a:prstGeom>
-          <a:noFill/>
-        </p:spPr>
-        <p:txBody>
-          <a:bodyPr wrap="square">
-            <a:spAutoFit/>
-          </a:bodyPr>
-          <a:lstStyle/>
-          <a:p>
-            <a:pPr algn="l"/>
-            <a:r>
-              <a:rPr sz="2800" b="0" i="0">
-                <a:solidFill>
-                  <a:srgbClr val="FFFFFF"/>
-                </a:solidFill>
-              </a:rPr>
-              <a:t>📮</a:t>
-            </a:r>
-          </a:p>
-        </p:txBody>
-      </p:sp>
-      <p:sp>
-        <p:nvSpPr>
-          <p:cNvPr id="25" name="TextBox 24"/>
-          <p:cNvSpPr txBox="1"/>
-          <p:nvPr/>
-        </p:nvSpPr>
-        <p:spPr>
-          <a:xfrm>
-            <a:off x="5148071" y="2999232"/>
-            <a:ext cx="1325880" cy="530352"/>
+          <p:cNvPr id="12" name="TextBox 11"/>
+          <p:cNvSpPr txBox="1"/>
+          <p:nvPr/>
+        </p:nvSpPr>
+        <p:spPr>
+          <a:xfrm>
+            <a:off x="3493008" y="1682496"/>
+            <a:ext cx="1097280" cy="594360"/>
           </a:xfrm>
           <a:prstGeom prst="rect">
             <a:avLst/>
@@ -11828,21 +11351,21 @@
                   <a:srgbClr val="4CC8C3"/>
                 </a:solidFill>
               </a:rPr>
-              <a:t>806K+</a:t>
-            </a:r>
-          </a:p>
-        </p:txBody>
-      </p:sp>
-      <p:sp>
-        <p:nvSpPr>
-          <p:cNvPr id="26" name="TextBox 25"/>
-          <p:cNvSpPr txBox="1"/>
-          <p:nvPr/>
-        </p:nvSpPr>
-        <p:spPr>
-          <a:xfrm>
-            <a:off x="5148071" y="3493008"/>
-            <a:ext cx="1463040" cy="274320"/>
+              <a:t>150K+</a:t>
+            </a:r>
+          </a:p>
+        </p:txBody>
+      </p:sp>
+      <p:sp>
+        <p:nvSpPr>
+          <p:cNvPr id="13" name="TextBox 12"/>
+          <p:cNvSpPr txBox="1"/>
+          <p:nvPr/>
+        </p:nvSpPr>
+        <p:spPr>
+          <a:xfrm>
+            <a:off x="4590288" y="1664208"/>
+            <a:ext cx="1463040" cy="1005840"/>
           </a:xfrm>
           <a:prstGeom prst="rect">
             <a:avLst/>
@@ -11859,93 +11382,25 @@
             <a:r>
               <a:rPr sz="1000" b="0" i="0">
                 <a:solidFill>
-                  <a:srgbClr val="A0E1DF"/>
-                </a:solidFill>
-              </a:rPr>
-              <a:t>members worldwide</a:t>
-            </a:r>
-          </a:p>
-        </p:txBody>
-      </p:sp>
-      <p:sp>
-        <p:nvSpPr>
-          <p:cNvPr id="27" name="TextBox 26"/>
-          <p:cNvSpPr txBox="1"/>
-          <p:nvPr/>
-        </p:nvSpPr>
-        <p:spPr>
-          <a:xfrm>
-            <a:off x="6519671" y="2999232"/>
-            <a:ext cx="1508760" cy="347472"/>
-          </a:xfrm>
-          <a:prstGeom prst="rect">
-            <a:avLst/>
-          </a:prstGeom>
-          <a:noFill/>
-        </p:spPr>
-        <p:txBody>
-          <a:bodyPr wrap="square">
-            <a:spAutoFit/>
-          </a:bodyPr>
-          <a:lstStyle/>
-          <a:p>
-            <a:pPr algn="l"/>
-            <a:r>
-              <a:rPr sz="1200" b="1" i="0">
-                <a:solidFill>
-                  <a:srgbClr val="FFFFFF"/>
-                </a:solidFill>
-              </a:rPr>
-              <a:t>Postcrossing</a:t>
-            </a:r>
-          </a:p>
-        </p:txBody>
-      </p:sp>
-      <p:sp>
-        <p:nvSpPr>
-          <p:cNvPr id="28" name="TextBox 27"/>
-          <p:cNvSpPr txBox="1"/>
-          <p:nvPr/>
-        </p:nvSpPr>
-        <p:spPr>
-          <a:xfrm>
-            <a:off x="6519671" y="3364992"/>
-            <a:ext cx="1508760" cy="868680"/>
-          </a:xfrm>
-          <a:prstGeom prst="rect">
-            <a:avLst/>
-          </a:prstGeom>
-          <a:noFill/>
-        </p:spPr>
-        <p:txBody>
-          <a:bodyPr wrap="square">
-            <a:spAutoFit/>
-          </a:bodyPr>
-          <a:lstStyle/>
-          <a:p>
-            <a:pPr algn="l"/>
-            <a:r>
-              <a:rPr sz="1000" b="0" i="0">
-                <a:solidFill>
-                  <a:srgbClr val="88AAA8"/>
-                </a:solidFill>
-              </a:rPr>
-              <a:t>87M+ postcards exchanged
-worldwide since 2005</a:t>
-            </a:r>
-          </a:p>
-        </p:txBody>
-      </p:sp>
-      <p:sp>
-        <p:nvSpPr>
-          <p:cNvPr id="29" name="Rounded Rectangle 28"/>
+                  <a:srgbClr val="E8F4F3"/>
+                </a:solidFill>
+              </a:rPr>
+              <a:t>TikTok posts
+tagged #snailmail</a:t>
+            </a:r>
+          </a:p>
+        </p:txBody>
+      </p:sp>
+      <p:sp>
+        <p:nvSpPr>
+          <p:cNvPr id="14" name="Rounded Rectangle 13"/>
           <p:cNvSpPr/>
           <p:nvPr/>
         </p:nvSpPr>
         <p:spPr>
           <a:xfrm>
-            <a:off x="8284462" y="2926080"/>
-            <a:ext cx="3749039" cy="1417320"/>
+            <a:off x="6254496" y="1600200"/>
+            <a:ext cx="2788920" cy="1188720"/>
           </a:xfrm>
           <a:prstGeom prst="roundRect">
             <a:avLst>
@@ -11983,14 +11438,14 @@
       </p:sp>
       <p:sp>
         <p:nvSpPr>
-          <p:cNvPr id="30" name="Rectangle 29"/>
+          <p:cNvPr id="15" name="Rectangle 14"/>
           <p:cNvSpPr/>
           <p:nvPr/>
         </p:nvSpPr>
         <p:spPr>
           <a:xfrm>
-            <a:off x="8284462" y="2926080"/>
-            <a:ext cx="45720" cy="1417320"/>
+            <a:off x="6254496" y="1600200"/>
+            <a:ext cx="2788920" cy="45720"/>
           </a:xfrm>
           <a:prstGeom prst="rect">
             <a:avLst/>
@@ -12026,48 +11481,14 @@
       </p:sp>
       <p:sp>
         <p:nvSpPr>
-          <p:cNvPr id="31" name="TextBox 30"/>
-          <p:cNvSpPr txBox="1"/>
-          <p:nvPr/>
-        </p:nvSpPr>
-        <p:spPr>
-          <a:xfrm>
-            <a:off x="8394190" y="3017520"/>
-            <a:ext cx="594360" cy="640080"/>
-          </a:xfrm>
-          <a:prstGeom prst="rect">
-            <a:avLst/>
-          </a:prstGeom>
-          <a:noFill/>
-        </p:spPr>
-        <p:txBody>
-          <a:bodyPr wrap="square">
-            <a:spAutoFit/>
-          </a:bodyPr>
-          <a:lstStyle/>
-          <a:p>
-            <a:pPr algn="l"/>
-            <a:r>
-              <a:rPr sz="2800" b="0" i="0">
-                <a:solidFill>
-                  <a:srgbClr val="FFFFFF"/>
-                </a:solidFill>
-              </a:rPr>
-              <a:t>💌</a:t>
-            </a:r>
-          </a:p>
-        </p:txBody>
-      </p:sp>
-      <p:sp>
-        <p:nvSpPr>
-          <p:cNvPr id="32" name="TextBox 31"/>
-          <p:cNvSpPr txBox="1"/>
-          <p:nvPr/>
-        </p:nvSpPr>
-        <p:spPr>
-          <a:xfrm>
-            <a:off x="9061702" y="2999232"/>
-            <a:ext cx="1325880" cy="530352"/>
+          <p:cNvPr id="16" name="TextBox 15"/>
+          <p:cNvSpPr txBox="1"/>
+          <p:nvPr/>
+        </p:nvSpPr>
+        <p:spPr>
+          <a:xfrm>
+            <a:off x="6391656" y="1682496"/>
+            <a:ext cx="1097280" cy="594360"/>
           </a:xfrm>
           <a:prstGeom prst="rect">
             <a:avLst/>
@@ -12087,21 +11508,21 @@
                   <a:srgbClr val="4CC8C3"/>
                 </a:solidFill>
               </a:rPr>
-              <a:t>1M+</a:t>
-            </a:r>
-          </a:p>
-        </p:txBody>
-      </p:sp>
-      <p:sp>
-        <p:nvSpPr>
-          <p:cNvPr id="33" name="TextBox 32"/>
-          <p:cNvSpPr txBox="1"/>
-          <p:nvPr/>
-        </p:nvSpPr>
-        <p:spPr>
-          <a:xfrm>
-            <a:off x="9061702" y="3493008"/>
-            <a:ext cx="1463040" cy="274320"/>
+              <a:t>~50%</a:t>
+            </a:r>
+          </a:p>
+        </p:txBody>
+      </p:sp>
+      <p:sp>
+        <p:nvSpPr>
+          <p:cNvPr id="17" name="TextBox 16"/>
+          <p:cNvSpPr txBox="1"/>
+          <p:nvPr/>
+        </p:nvSpPr>
+        <p:spPr>
+          <a:xfrm>
+            <a:off x="7488936" y="1664208"/>
+            <a:ext cx="1463040" cy="1005840"/>
           </a:xfrm>
           <a:prstGeom prst="rect">
             <a:avLst/>
@@ -12118,93 +11539,26 @@
             <a:r>
               <a:rPr sz="1000" b="0" i="0">
                 <a:solidFill>
-                  <a:srgbClr val="A0E1DF"/>
-                </a:solidFill>
-              </a:rPr>
-              <a:t>letters delivered</a:t>
-            </a:r>
-          </a:p>
-        </p:txBody>
-      </p:sp>
-      <p:sp>
-        <p:nvSpPr>
-          <p:cNvPr id="34" name="TextBox 33"/>
-          <p:cNvSpPr txBox="1"/>
-          <p:nvPr/>
-        </p:nvSpPr>
-        <p:spPr>
-          <a:xfrm>
-            <a:off x="10433302" y="2999232"/>
-            <a:ext cx="1508760" cy="347472"/>
-          </a:xfrm>
-          <a:prstGeom prst="rect">
-            <a:avLst/>
-          </a:prstGeom>
-          <a:noFill/>
-        </p:spPr>
-        <p:txBody>
-          <a:bodyPr wrap="square">
-            <a:spAutoFit/>
-          </a:bodyPr>
-          <a:lstStyle/>
-          <a:p>
-            <a:pPr algn="l"/>
-            <a:r>
-              <a:rPr sz="1200" b="1" i="0">
-                <a:solidFill>
-                  <a:srgbClr val="FFFFFF"/>
-                </a:solidFill>
-              </a:rPr>
-              <a:t>Letters Against Isolation</a:t>
-            </a:r>
-          </a:p>
-        </p:txBody>
-      </p:sp>
-      <p:sp>
-        <p:nvSpPr>
-          <p:cNvPr id="35" name="TextBox 34"/>
-          <p:cNvSpPr txBox="1"/>
-          <p:nvPr/>
-        </p:nvSpPr>
-        <p:spPr>
-          <a:xfrm>
-            <a:off x="10433302" y="3364992"/>
-            <a:ext cx="1508760" cy="868680"/>
-          </a:xfrm>
-          <a:prstGeom prst="rect">
-            <a:avLst/>
-          </a:prstGeom>
-          <a:noFill/>
-        </p:spPr>
-        <p:txBody>
-          <a:bodyPr wrap="square">
-            <a:spAutoFit/>
-          </a:bodyPr>
-          <a:lstStyle/>
-          <a:p>
-            <a:pPr algn="l"/>
-            <a:r>
-              <a:rPr sz="1000" b="0" i="0">
-                <a:solidFill>
-                  <a:srgbClr val="88AAA8"/>
-                </a:solidFill>
-              </a:rPr>
-              <a:t>Launched during COVID
-complete strangers writing</a:t>
-            </a:r>
-          </a:p>
-        </p:txBody>
-      </p:sp>
-      <p:sp>
-        <p:nvSpPr>
-          <p:cNvPr id="36" name="Rounded Rectangle 35"/>
+                  <a:srgbClr val="E8F4F3"/>
+                </a:solidFill>
+              </a:rPr>
+              <a:t>of Gen Z mails
+something monthly
+(Stamps.com)</a:t>
+            </a:r>
+          </a:p>
+        </p:txBody>
+      </p:sp>
+      <p:sp>
+        <p:nvSpPr>
+          <p:cNvPr id="18" name="Rounded Rectangle 17"/>
           <p:cNvSpPr/>
           <p:nvPr/>
         </p:nvSpPr>
         <p:spPr>
           <a:xfrm>
-            <a:off x="457200" y="4471416"/>
-            <a:ext cx="3749039" cy="1417320"/>
+            <a:off x="9153144" y="1600200"/>
+            <a:ext cx="2788920" cy="1188720"/>
           </a:xfrm>
           <a:prstGeom prst="roundRect">
             <a:avLst>
@@ -12242,20 +11596,20 @@
       </p:sp>
       <p:sp>
         <p:nvSpPr>
-          <p:cNvPr id="37" name="Rectangle 36"/>
+          <p:cNvPr id="19" name="Rectangle 18"/>
           <p:cNvSpPr/>
           <p:nvPr/>
         </p:nvSpPr>
         <p:spPr>
           <a:xfrm>
-            <a:off x="457200" y="4471416"/>
-            <a:ext cx="45720" cy="1417320"/>
+            <a:off x="9153144" y="1600200"/>
+            <a:ext cx="2788920" cy="45720"/>
           </a:xfrm>
           <a:prstGeom prst="rect">
             <a:avLst/>
           </a:prstGeom>
           <a:solidFill>
-            <a:srgbClr val="28807D"/>
+            <a:srgbClr val="4CC8C3"/>
           </a:solidFill>
           <a:ln>
             <a:noFill/>
@@ -12285,48 +11639,14 @@
       </p:sp>
       <p:sp>
         <p:nvSpPr>
-          <p:cNvPr id="38" name="TextBox 37"/>
-          <p:cNvSpPr txBox="1"/>
-          <p:nvPr/>
-        </p:nvSpPr>
-        <p:spPr>
-          <a:xfrm>
-            <a:off x="566928" y="4562856"/>
-            <a:ext cx="594360" cy="640080"/>
-          </a:xfrm>
-          <a:prstGeom prst="rect">
-            <a:avLst/>
-          </a:prstGeom>
-          <a:noFill/>
-        </p:spPr>
-        <p:txBody>
-          <a:bodyPr wrap="square">
-            <a:spAutoFit/>
-          </a:bodyPr>
-          <a:lstStyle/>
-          <a:p>
-            <a:pPr algn="l"/>
-            <a:r>
-              <a:rPr sz="2800" b="0" i="0">
-                <a:solidFill>
-                  <a:srgbClr val="FFFFFF"/>
-                </a:solidFill>
-              </a:rPr>
-              <a:t>🤝</a:t>
-            </a:r>
-          </a:p>
-        </p:txBody>
-      </p:sp>
-      <p:sp>
-        <p:nvSpPr>
-          <p:cNvPr id="39" name="TextBox 38"/>
-          <p:cNvSpPr txBox="1"/>
-          <p:nvPr/>
-        </p:nvSpPr>
-        <p:spPr>
-          <a:xfrm>
-            <a:off x="1234440" y="4544568"/>
-            <a:ext cx="1325880" cy="530352"/>
+          <p:cNvPr id="20" name="TextBox 19"/>
+          <p:cNvSpPr txBox="1"/>
+          <p:nvPr/>
+        </p:nvSpPr>
+        <p:spPr>
+          <a:xfrm>
+            <a:off x="9290304" y="1682496"/>
+            <a:ext cx="1097280" cy="594360"/>
           </a:xfrm>
           <a:prstGeom prst="rect">
             <a:avLst/>
@@ -12346,21 +11666,21 @@
                   <a:srgbClr val="4CC8C3"/>
                 </a:solidFill>
               </a:rPr>
-              <a:t>1M+</a:t>
-            </a:r>
-          </a:p>
-        </p:txBody>
-      </p:sp>
-      <p:sp>
-        <p:nvSpPr>
-          <p:cNvPr id="40" name="TextBox 39"/>
-          <p:cNvSpPr txBox="1"/>
-          <p:nvPr/>
-        </p:nvSpPr>
-        <p:spPr>
-          <a:xfrm>
-            <a:off x="1234440" y="5038344"/>
-            <a:ext cx="1463040" cy="274320"/>
+              <a:t>63%</a:t>
+            </a:r>
+          </a:p>
+        </p:txBody>
+      </p:sp>
+      <p:sp>
+        <p:nvSpPr>
+          <p:cNvPr id="21" name="TextBox 20"/>
+          <p:cNvSpPr txBox="1"/>
+          <p:nvPr/>
+        </p:nvSpPr>
+        <p:spPr>
+          <a:xfrm>
+            <a:off x="10387584" y="1664208"/>
+            <a:ext cx="1463040" cy="1005840"/>
           </a:xfrm>
           <a:prstGeom prst="rect">
             <a:avLst/>
@@ -12377,93 +11697,60 @@
             <a:r>
               <a:rPr sz="1000" b="0" i="0">
                 <a:solidFill>
-                  <a:srgbClr val="A0E1DF"/>
-                </a:solidFill>
-              </a:rPr>
-              <a:t>letters sent</a:t>
-            </a:r>
-          </a:p>
-        </p:txBody>
-      </p:sp>
-      <p:sp>
-        <p:nvSpPr>
-          <p:cNvPr id="41" name="TextBox 40"/>
-          <p:cNvSpPr txBox="1"/>
-          <p:nvPr/>
-        </p:nvSpPr>
-        <p:spPr>
-          <a:xfrm>
-            <a:off x="2606040" y="4544568"/>
-            <a:ext cx="1508760" cy="347472"/>
-          </a:xfrm>
-          <a:prstGeom prst="rect">
-            <a:avLst/>
-          </a:prstGeom>
-          <a:noFill/>
-        </p:spPr>
-        <p:txBody>
-          <a:bodyPr wrap="square">
-            <a:spAutoFit/>
-          </a:bodyPr>
-          <a:lstStyle/>
-          <a:p>
-            <a:pPr algn="l"/>
-            <a:r>
-              <a:rPr sz="1200" b="1" i="0">
-                <a:solidFill>
-                  <a:srgbClr val="FFFFFF"/>
-                </a:solidFill>
-              </a:rPr>
-              <a:t>Love For Our Elders</a:t>
-            </a:r>
-          </a:p>
-        </p:txBody>
-      </p:sp>
-      <p:sp>
-        <p:nvSpPr>
-          <p:cNvPr id="42" name="TextBox 41"/>
-          <p:cNvSpPr txBox="1"/>
-          <p:nvPr/>
-        </p:nvSpPr>
-        <p:spPr>
-          <a:xfrm>
-            <a:off x="2606040" y="4910328"/>
-            <a:ext cx="1508760" cy="868680"/>
-          </a:xfrm>
-          <a:prstGeom prst="rect">
-            <a:avLst/>
-          </a:prstGeom>
-          <a:noFill/>
-        </p:spPr>
-        <p:txBody>
-          <a:bodyPr wrap="square">
-            <a:spAutoFit/>
-          </a:bodyPr>
-          <a:lstStyle/>
-          <a:p>
-            <a:pPr algn="l"/>
-            <a:r>
-              <a:rPr sz="1000" b="0" i="0">
-                <a:solidFill>
-                  <a:srgbClr val="88AAA8"/>
-                </a:solidFill>
-              </a:rPr>
-              <a:t>100+ chapters · 70+
-mailboxes globally</a:t>
-            </a:r>
-          </a:p>
-        </p:txBody>
-      </p:sp>
-      <p:sp>
-        <p:nvSpPr>
-          <p:cNvPr id="43" name="Rounded Rectangle 42"/>
+                  <a:srgbClr val="E8F4F3"/>
+                </a:solidFill>
+              </a:rPr>
+              <a:t>of Gen Z intentionally
+cutting screen time
+(Talker Research)</a:t>
+            </a:r>
+          </a:p>
+        </p:txBody>
+      </p:sp>
+      <p:sp>
+        <p:nvSpPr>
+          <p:cNvPr id="22" name="TextBox 21"/>
+          <p:cNvSpPr txBox="1"/>
+          <p:nvPr/>
+        </p:nvSpPr>
+        <p:spPr>
+          <a:xfrm>
+            <a:off x="457200" y="2852928"/>
+            <a:ext cx="7315200" cy="320040"/>
+          </a:xfrm>
+          <a:prstGeom prst="rect">
+            <a:avLst/>
+          </a:prstGeom>
+          <a:noFill/>
+        </p:spPr>
+        <p:txBody>
+          <a:bodyPr wrap="square">
+            <a:spAutoFit/>
+          </a:bodyPr>
+          <a:lstStyle/>
+          <a:p>
+            <a:pPr algn="l"/>
+            <a:r>
+              <a:rPr sz="900" b="1" i="0">
+                <a:solidFill>
+                  <a:srgbClr val="4CC8C3"/>
+                </a:solidFill>
+              </a:rPr>
+              <a:t>REAL CREATORS  ·  REAL REVENUE  ·  ZERO PAID ADS</a:t>
+            </a:r>
+          </a:p>
+        </p:txBody>
+      </p:sp>
+      <p:sp>
+        <p:nvSpPr>
+          <p:cNvPr id="23" name="Rounded Rectangle 22"/>
           <p:cNvSpPr/>
           <p:nvPr/>
         </p:nvSpPr>
         <p:spPr>
           <a:xfrm>
-            <a:off x="4370831" y="4471416"/>
-            <a:ext cx="3749039" cy="1417320"/>
+            <a:off x="457200" y="3218688"/>
+            <a:ext cx="2788920" cy="1874519"/>
           </a:xfrm>
           <a:prstGeom prst="roundRect">
             <a:avLst>
@@ -12471,7 +11758,7 @@
             </a:avLst>
           </a:prstGeom>
           <a:solidFill>
-            <a:srgbClr val="103232"/>
+            <a:srgbClr val="143E3E"/>
           </a:solidFill>
           <a:ln>
             <a:noFill/>
@@ -12501,20 +11788,20 @@
       </p:sp>
       <p:sp>
         <p:nvSpPr>
-          <p:cNvPr id="44" name="Rectangle 43"/>
+          <p:cNvPr id="24" name="Rectangle 23"/>
           <p:cNvSpPr/>
           <p:nvPr/>
         </p:nvSpPr>
         <p:spPr>
           <a:xfrm>
-            <a:off x="4370831" y="4471416"/>
-            <a:ext cx="45720" cy="1417320"/>
+            <a:off x="457200" y="3218688"/>
+            <a:ext cx="2788920" cy="45720"/>
           </a:xfrm>
           <a:prstGeom prst="rect">
             <a:avLst/>
           </a:prstGeom>
           <a:solidFill>
-            <a:srgbClr val="28807D"/>
+            <a:srgbClr val="4CC8C3"/>
           </a:solidFill>
           <a:ln>
             <a:noFill/>
@@ -12544,82 +11831,116 @@
       </p:sp>
       <p:sp>
         <p:nvSpPr>
-          <p:cNvPr id="45" name="TextBox 44"/>
-          <p:cNvSpPr txBox="1"/>
-          <p:nvPr/>
-        </p:nvSpPr>
-        <p:spPr>
-          <a:xfrm>
-            <a:off x="4480559" y="4562856"/>
-            <a:ext cx="594360" cy="640080"/>
-          </a:xfrm>
-          <a:prstGeom prst="rect">
-            <a:avLst/>
-          </a:prstGeom>
-          <a:noFill/>
-        </p:spPr>
-        <p:txBody>
-          <a:bodyPr wrap="square">
-            <a:spAutoFit/>
-          </a:bodyPr>
-          <a:lstStyle/>
-          <a:p>
-            <a:pPr algn="l"/>
-            <a:r>
-              <a:rPr sz="2800" b="0" i="0">
+          <p:cNvPr id="25" name="TextBox 24"/>
+          <p:cNvSpPr txBox="1"/>
+          <p:nvPr/>
+        </p:nvSpPr>
+        <p:spPr>
+          <a:xfrm>
+            <a:off x="594360" y="3310128"/>
+            <a:ext cx="502920" cy="502920"/>
+          </a:xfrm>
+          <a:prstGeom prst="rect">
+            <a:avLst/>
+          </a:prstGeom>
+          <a:noFill/>
+        </p:spPr>
+        <p:txBody>
+          <a:bodyPr wrap="square">
+            <a:spAutoFit/>
+          </a:bodyPr>
+          <a:lstStyle/>
+          <a:p>
+            <a:pPr algn="l"/>
+            <a:r>
+              <a:rPr sz="2600" b="0" i="0">
                 <a:solidFill>
                   <a:srgbClr val="FFFFFF"/>
                 </a:solidFill>
               </a:rPr>
-              <a:t>🌍</a:t>
-            </a:r>
-          </a:p>
-        </p:txBody>
-      </p:sp>
-      <p:sp>
-        <p:nvSpPr>
-          <p:cNvPr id="46" name="TextBox 45"/>
-          <p:cNvSpPr txBox="1"/>
-          <p:nvPr/>
-        </p:nvSpPr>
-        <p:spPr>
-          <a:xfrm>
-            <a:off x="5148071" y="4544568"/>
-            <a:ext cx="1325880" cy="530352"/>
-          </a:xfrm>
-          <a:prstGeom prst="rect">
-            <a:avLst/>
-          </a:prstGeom>
-          <a:noFill/>
-        </p:spPr>
-        <p:txBody>
-          <a:bodyPr wrap="square">
-            <a:spAutoFit/>
-          </a:bodyPr>
-          <a:lstStyle/>
-          <a:p>
-            <a:pPr algn="l"/>
-            <a:r>
-              <a:rPr sz="3000" b="1" i="0">
+              <a:t>✉️</a:t>
+            </a:r>
+          </a:p>
+        </p:txBody>
+      </p:sp>
+      <p:sp>
+        <p:nvSpPr>
+          <p:cNvPr id="26" name="TextBox 25"/>
+          <p:cNvSpPr txBox="1"/>
+          <p:nvPr/>
+        </p:nvSpPr>
+        <p:spPr>
+          <a:xfrm>
+            <a:off x="1115568" y="3310128"/>
+            <a:ext cx="2011680" cy="502920"/>
+          </a:xfrm>
+          <a:prstGeom prst="rect">
+            <a:avLst/>
+          </a:prstGeom>
+          <a:noFill/>
+        </p:spPr>
+        <p:txBody>
+          <a:bodyPr wrap="square">
+            <a:spAutoFit/>
+          </a:bodyPr>
+          <a:lstStyle/>
+          <a:p>
+            <a:pPr algn="l"/>
+            <a:r>
+              <a:rPr sz="2200" b="1" i="0">
                 <a:solidFill>
                   <a:srgbClr val="4CC8C3"/>
                 </a:solidFill>
               </a:rPr>
-              <a:t>All 50</a:t>
-            </a:r>
-          </a:p>
-        </p:txBody>
-      </p:sp>
-      <p:sp>
-        <p:nvSpPr>
-          <p:cNvPr id="47" name="TextBox 46"/>
-          <p:cNvSpPr txBox="1"/>
-          <p:nvPr/>
-        </p:nvSpPr>
-        <p:spPr>
-          <a:xfrm>
-            <a:off x="5148071" y="5038344"/>
-            <a:ext cx="1463040" cy="274320"/>
+              <a:t>$45K/mo</a:t>
+            </a:r>
+          </a:p>
+        </p:txBody>
+      </p:sp>
+      <p:sp>
+        <p:nvSpPr>
+          <p:cNvPr id="27" name="TextBox 26"/>
+          <p:cNvSpPr txBox="1"/>
+          <p:nvPr/>
+        </p:nvSpPr>
+        <p:spPr>
+          <a:xfrm>
+            <a:off x="594360" y="3813048"/>
+            <a:ext cx="2514600" cy="365760"/>
+          </a:xfrm>
+          <a:prstGeom prst="rect">
+            <a:avLst/>
+          </a:prstGeom>
+          <a:noFill/>
+        </p:spPr>
+        <p:txBody>
+          <a:bodyPr wrap="square">
+            <a:spAutoFit/>
+          </a:bodyPr>
+          <a:lstStyle/>
+          <a:p>
+            <a:pPr algn="l"/>
+            <a:r>
+              <a:rPr sz="1300" b="1" i="0">
+                <a:solidFill>
+                  <a:srgbClr val="FFFFFF"/>
+                </a:solidFill>
+              </a:rPr>
+              <a:t>The Tiny Post</a:t>
+            </a:r>
+          </a:p>
+        </p:txBody>
+      </p:sp>
+      <p:sp>
+        <p:nvSpPr>
+          <p:cNvPr id="28" name="TextBox 27"/>
+          <p:cNvSpPr txBox="1"/>
+          <p:nvPr/>
+        </p:nvSpPr>
+        <p:spPr>
+          <a:xfrm>
+            <a:off x="594360" y="4178808"/>
+            <a:ext cx="2514600" cy="804672"/>
           </a:xfrm>
           <a:prstGeom prst="rect">
             <a:avLst/>
@@ -12636,93 +11957,26 @@
             <a:r>
               <a:rPr sz="1000" b="0" i="0">
                 <a:solidFill>
-                  <a:srgbClr val="A0E1DF"/>
-                </a:solidFill>
-              </a:rPr>
-              <a:t>states + 70+ countries</a:t>
-            </a:r>
-          </a:p>
-        </p:txBody>
-      </p:sp>
-      <p:sp>
-        <p:nvSpPr>
-          <p:cNvPr id="48" name="TextBox 47"/>
-          <p:cNvSpPr txBox="1"/>
-          <p:nvPr/>
-        </p:nvSpPr>
-        <p:spPr>
-          <a:xfrm>
-            <a:off x="6519671" y="4544568"/>
-            <a:ext cx="1508760" cy="347472"/>
-          </a:xfrm>
-          <a:prstGeom prst="rect">
-            <a:avLst/>
-          </a:prstGeom>
-          <a:noFill/>
-        </p:spPr>
-        <p:txBody>
-          <a:bodyPr wrap="square">
-            <a:spAutoFit/>
-          </a:bodyPr>
-          <a:lstStyle/>
-          <a:p>
-            <a:pPr algn="l"/>
-            <a:r>
-              <a:rPr sz="1200" b="1" i="0">
-                <a:solidFill>
-                  <a:srgbClr val="FFFFFF"/>
-                </a:solidFill>
-              </a:rPr>
-              <a:t>More Love Letters</a:t>
-            </a:r>
-          </a:p>
-        </p:txBody>
-      </p:sp>
-      <p:sp>
-        <p:nvSpPr>
-          <p:cNvPr id="49" name="TextBox 48"/>
-          <p:cNvSpPr txBox="1"/>
-          <p:nvPr/>
-        </p:nvSpPr>
-        <p:spPr>
-          <a:xfrm>
-            <a:off x="6519671" y="4910328"/>
-            <a:ext cx="1508760" cy="868680"/>
-          </a:xfrm>
-          <a:prstGeom prst="rect">
-            <a:avLst/>
-          </a:prstGeom>
-          <a:noFill/>
-        </p:spPr>
-        <p:txBody>
-          <a:bodyPr wrap="square">
-            <a:spAutoFit/>
-          </a:bodyPr>
-          <a:lstStyle/>
-          <a:p>
-            <a:pPr algn="l"/>
-            <a:r>
-              <a:rPr sz="1000" b="0" i="0">
-                <a:solidFill>
                   <a:srgbClr val="88AAA8"/>
                 </a:solidFill>
               </a:rPr>
-              <a:t>Active in every US state
-encouragement at scale</a:t>
-            </a:r>
-          </a:p>
-        </p:txBody>
-      </p:sp>
-      <p:sp>
-        <p:nvSpPr>
-          <p:cNvPr id="50" name="Rounded Rectangle 49"/>
+              <a:t>Hannah Gustafson · Austin TX
+5,000 subs · $11/mo
+0 paid ads, 0 PR</a:t>
+            </a:r>
+          </a:p>
+        </p:txBody>
+      </p:sp>
+      <p:sp>
+        <p:nvSpPr>
+          <p:cNvPr id="29" name="Rounded Rectangle 28"/>
           <p:cNvSpPr/>
           <p:nvPr/>
         </p:nvSpPr>
         <p:spPr>
           <a:xfrm>
-            <a:off x="8284462" y="4471416"/>
-            <a:ext cx="3749039" cy="1417320"/>
+            <a:off x="3355848" y="3218688"/>
+            <a:ext cx="2788920" cy="1874519"/>
           </a:xfrm>
           <a:prstGeom prst="roundRect">
             <a:avLst>
@@ -12730,7 +11984,7 @@
             </a:avLst>
           </a:prstGeom>
           <a:solidFill>
-            <a:srgbClr val="103232"/>
+            <a:srgbClr val="143E3E"/>
           </a:solidFill>
           <a:ln>
             <a:noFill/>
@@ -12760,20 +12014,20 @@
       </p:sp>
       <p:sp>
         <p:nvSpPr>
-          <p:cNvPr id="51" name="Rectangle 50"/>
+          <p:cNvPr id="30" name="Rectangle 29"/>
           <p:cNvSpPr/>
           <p:nvPr/>
         </p:nvSpPr>
         <p:spPr>
           <a:xfrm>
-            <a:off x="8284462" y="4471416"/>
-            <a:ext cx="45720" cy="1417320"/>
+            <a:off x="3355848" y="3218688"/>
+            <a:ext cx="2788920" cy="45720"/>
           </a:xfrm>
           <a:prstGeom prst="rect">
             <a:avLst/>
           </a:prstGeom>
           <a:solidFill>
-            <a:srgbClr val="28807D"/>
+            <a:srgbClr val="4CC8C3"/>
           </a:solidFill>
           <a:ln>
             <a:noFill/>
@@ -12803,35 +12057,818 @@
       </p:sp>
       <p:sp>
         <p:nvSpPr>
-          <p:cNvPr id="52" name="TextBox 51"/>
-          <p:cNvSpPr txBox="1"/>
-          <p:nvPr/>
-        </p:nvSpPr>
-        <p:spPr>
-          <a:xfrm>
-            <a:off x="8394190" y="4562856"/>
-            <a:ext cx="594360" cy="640080"/>
-          </a:xfrm>
-          <a:prstGeom prst="rect">
-            <a:avLst/>
-          </a:prstGeom>
-          <a:noFill/>
-        </p:spPr>
-        <p:txBody>
-          <a:bodyPr wrap="square">
-            <a:spAutoFit/>
-          </a:bodyPr>
-          <a:lstStyle/>
-          <a:p>
-            <a:pPr algn="l"/>
-            <a:r>
-              <a:rPr sz="2800" b="0" i="0">
+          <p:cNvPr id="31" name="TextBox 30"/>
+          <p:cNvSpPr txBox="1"/>
+          <p:nvPr/>
+        </p:nvSpPr>
+        <p:spPr>
+          <a:xfrm>
+            <a:off x="3493008" y="3310128"/>
+            <a:ext cx="502920" cy="502920"/>
+          </a:xfrm>
+          <a:prstGeom prst="rect">
+            <a:avLst/>
+          </a:prstGeom>
+          <a:noFill/>
+        </p:spPr>
+        <p:txBody>
+          <a:bodyPr wrap="square">
+            <a:spAutoFit/>
+          </a:bodyPr>
+          <a:lstStyle/>
+          <a:p>
+            <a:pPr algn="l"/>
+            <a:r>
+              <a:rPr sz="2600" b="0" i="0">
                 <a:solidFill>
                   <a:srgbClr val="FFFFFF"/>
                 </a:solidFill>
               </a:rPr>
-              <a:t>📖</a:t>
-            </a:r>
+              <a:t>🏛️</a:t>
+            </a:r>
+          </a:p>
+        </p:txBody>
+      </p:sp>
+      <p:sp>
+        <p:nvSpPr>
+          <p:cNvPr id="32" name="TextBox 31"/>
+          <p:cNvSpPr txBox="1"/>
+          <p:nvPr/>
+        </p:nvSpPr>
+        <p:spPr>
+          <a:xfrm>
+            <a:off x="4014216" y="3310128"/>
+            <a:ext cx="2011680" cy="502920"/>
+          </a:xfrm>
+          <a:prstGeom prst="rect">
+            <a:avLst/>
+          </a:prstGeom>
+          <a:noFill/>
+        </p:spPr>
+        <p:txBody>
+          <a:bodyPr wrap="square">
+            <a:spAutoFit/>
+          </a:bodyPr>
+          <a:lstStyle/>
+          <a:p>
+            <a:pPr algn="l"/>
+            <a:r>
+              <a:rPr sz="2200" b="1" i="0">
+                <a:solidFill>
+                  <a:srgbClr val="4CC8C3"/>
+                </a:solidFill>
+              </a:rPr>
+              <a:t>$18,300/mo</a:t>
+            </a:r>
+          </a:p>
+        </p:txBody>
+      </p:sp>
+      <p:sp>
+        <p:nvSpPr>
+          <p:cNvPr id="33" name="TextBox 32"/>
+          <p:cNvSpPr txBox="1"/>
+          <p:nvPr/>
+        </p:nvSpPr>
+        <p:spPr>
+          <a:xfrm>
+            <a:off x="3493008" y="3813048"/>
+            <a:ext cx="2514600" cy="365760"/>
+          </a:xfrm>
+          <a:prstGeom prst="rect">
+            <a:avLst/>
+          </a:prstGeom>
+          <a:noFill/>
+        </p:spPr>
+        <p:txBody>
+          <a:bodyPr wrap="square">
+            <a:spAutoFit/>
+          </a:bodyPr>
+          <a:lstStyle/>
+          <a:p>
+            <a:pPr algn="l"/>
+            <a:r>
+              <a:rPr sz="1300" b="1" i="0">
+                <a:solidFill>
+                  <a:srgbClr val="FFFFFF"/>
+                </a:solidFill>
+              </a:rPr>
+              <a:t>The Architecture Club</a:t>
+            </a:r>
+          </a:p>
+        </p:txBody>
+      </p:sp>
+      <p:sp>
+        <p:nvSpPr>
+          <p:cNvPr id="34" name="TextBox 33"/>
+          <p:cNvSpPr txBox="1"/>
+          <p:nvPr/>
+        </p:nvSpPr>
+        <p:spPr>
+          <a:xfrm>
+            <a:off x="3493008" y="4178808"/>
+            <a:ext cx="2514600" cy="804672"/>
+          </a:xfrm>
+          <a:prstGeom prst="rect">
+            <a:avLst/>
+          </a:prstGeom>
+          <a:noFill/>
+        </p:spPr>
+        <p:txBody>
+          <a:bodyPr wrap="square">
+            <a:spAutoFit/>
+          </a:bodyPr>
+          <a:lstStyle/>
+          <a:p>
+            <a:pPr algn="l"/>
+            <a:r>
+              <a:rPr sz="1000" b="0" i="0">
+                <a:solidFill>
+                  <a:srgbClr val="88AAA8"/>
+                </a:solidFill>
+              </a:rPr>
+              <a:t>Trinity Shiroma · Orlando FL
+2,700 subs · $8.88/mo
+1,300 subs in first 3 months</a:t>
+            </a:r>
+          </a:p>
+        </p:txBody>
+      </p:sp>
+      <p:sp>
+        <p:nvSpPr>
+          <p:cNvPr id="35" name="Rounded Rectangle 34"/>
+          <p:cNvSpPr/>
+          <p:nvPr/>
+        </p:nvSpPr>
+        <p:spPr>
+          <a:xfrm>
+            <a:off x="6254496" y="3218688"/>
+            <a:ext cx="2788920" cy="1874519"/>
+          </a:xfrm>
+          <a:prstGeom prst="roundRect">
+            <a:avLst>
+              <a:gd name="adj" fmla="val 8000"/>
+            </a:avLst>
+          </a:prstGeom>
+          <a:solidFill>
+            <a:srgbClr val="143E3E"/>
+          </a:solidFill>
+          <a:ln>
+            <a:noFill/>
+          </a:ln>
+        </p:spPr>
+        <p:style>
+          <a:lnRef idx="1">
+            <a:schemeClr val="accent1"/>
+          </a:lnRef>
+          <a:fillRef idx="3">
+            <a:schemeClr val="accent1"/>
+          </a:fillRef>
+          <a:effectRef idx="2">
+            <a:schemeClr val="accent1"/>
+          </a:effectRef>
+          <a:fontRef idx="minor">
+            <a:schemeClr val="lt1"/>
+          </a:fontRef>
+        </p:style>
+        <p:txBody>
+          <a:bodyPr rtlCol="0" anchor="ctr"/>
+          <a:lstStyle/>
+          <a:p>
+            <a:pPr algn="ctr"/>
+          </a:p>
+        </p:txBody>
+      </p:sp>
+      <p:sp>
+        <p:nvSpPr>
+          <p:cNvPr id="36" name="Rectangle 35"/>
+          <p:cNvSpPr/>
+          <p:nvPr/>
+        </p:nvSpPr>
+        <p:spPr>
+          <a:xfrm>
+            <a:off x="6254496" y="3218688"/>
+            <a:ext cx="2788920" cy="45720"/>
+          </a:xfrm>
+          <a:prstGeom prst="rect">
+            <a:avLst/>
+          </a:prstGeom>
+          <a:solidFill>
+            <a:srgbClr val="4CC8C3"/>
+          </a:solidFill>
+          <a:ln>
+            <a:noFill/>
+          </a:ln>
+        </p:spPr>
+        <p:style>
+          <a:lnRef idx="1">
+            <a:schemeClr val="accent1"/>
+          </a:lnRef>
+          <a:fillRef idx="3">
+            <a:schemeClr val="accent1"/>
+          </a:fillRef>
+          <a:effectRef idx="2">
+            <a:schemeClr val="accent1"/>
+          </a:effectRef>
+          <a:fontRef idx="minor">
+            <a:schemeClr val="lt1"/>
+          </a:fontRef>
+        </p:style>
+        <p:txBody>
+          <a:bodyPr rtlCol="0" anchor="ctr"/>
+          <a:lstStyle/>
+          <a:p>
+            <a:pPr algn="ctr"/>
+          </a:p>
+        </p:txBody>
+      </p:sp>
+      <p:sp>
+        <p:nvSpPr>
+          <p:cNvPr id="37" name="TextBox 36"/>
+          <p:cNvSpPr txBox="1"/>
+          <p:nvPr/>
+        </p:nvSpPr>
+        <p:spPr>
+          <a:xfrm>
+            <a:off x="6391656" y="3310128"/>
+            <a:ext cx="502920" cy="502920"/>
+          </a:xfrm>
+          <a:prstGeom prst="rect">
+            <a:avLst/>
+          </a:prstGeom>
+          <a:noFill/>
+        </p:spPr>
+        <p:txBody>
+          <a:bodyPr wrap="square">
+            <a:spAutoFit/>
+          </a:bodyPr>
+          <a:lstStyle/>
+          <a:p>
+            <a:pPr algn="l"/>
+            <a:r>
+              <a:rPr sz="2600" b="0" i="0">
+                <a:solidFill>
+                  <a:srgbClr val="FFFFFF"/>
+                </a:solidFill>
+              </a:rPr>
+              <a:t>🍝</a:t>
+            </a:r>
+          </a:p>
+        </p:txBody>
+      </p:sp>
+      <p:sp>
+        <p:nvSpPr>
+          <p:cNvPr id="38" name="TextBox 37"/>
+          <p:cNvSpPr txBox="1"/>
+          <p:nvPr/>
+        </p:nvSpPr>
+        <p:spPr>
+          <a:xfrm>
+            <a:off x="6912864" y="3310128"/>
+            <a:ext cx="2011680" cy="502920"/>
+          </a:xfrm>
+          <a:prstGeom prst="rect">
+            <a:avLst/>
+          </a:prstGeom>
+          <a:noFill/>
+        </p:spPr>
+        <p:txBody>
+          <a:bodyPr wrap="square">
+            <a:spAutoFit/>
+          </a:bodyPr>
+          <a:lstStyle/>
+          <a:p>
+            <a:pPr algn="l"/>
+            <a:r>
+              <a:rPr sz="2200" b="1" i="0">
+                <a:solidFill>
+                  <a:srgbClr val="4CC8C3"/>
+                </a:solidFill>
+              </a:rPr>
+              <a:t>4,000 subs</a:t>
+            </a:r>
+          </a:p>
+        </p:txBody>
+      </p:sp>
+      <p:sp>
+        <p:nvSpPr>
+          <p:cNvPr id="39" name="TextBox 38"/>
+          <p:cNvSpPr txBox="1"/>
+          <p:nvPr/>
+        </p:nvSpPr>
+        <p:spPr>
+          <a:xfrm>
+            <a:off x="6391656" y="3813048"/>
+            <a:ext cx="2514600" cy="365760"/>
+          </a:xfrm>
+          <a:prstGeom prst="rect">
+            <a:avLst/>
+          </a:prstGeom>
+          <a:noFill/>
+        </p:spPr>
+        <p:txBody>
+          <a:bodyPr wrap="square">
+            <a:spAutoFit/>
+          </a:bodyPr>
+          <a:lstStyle/>
+          <a:p>
+            <a:pPr algn="l"/>
+            <a:r>
+              <a:rPr sz="1300" b="1" i="0">
+                <a:solidFill>
+                  <a:srgbClr val="FFFFFF"/>
+                </a:solidFill>
+              </a:rPr>
+              <a:t>Little Kitchen of Bo</a:t>
+            </a:r>
+          </a:p>
+        </p:txBody>
+      </p:sp>
+      <p:sp>
+        <p:nvSpPr>
+          <p:cNvPr id="40" name="TextBox 39"/>
+          <p:cNvSpPr txBox="1"/>
+          <p:nvPr/>
+        </p:nvSpPr>
+        <p:spPr>
+          <a:xfrm>
+            <a:off x="6391656" y="4178808"/>
+            <a:ext cx="2514600" cy="804672"/>
+          </a:xfrm>
+          <a:prstGeom prst="rect">
+            <a:avLst/>
+          </a:prstGeom>
+          <a:noFill/>
+        </p:spPr>
+        <p:txBody>
+          <a:bodyPr wrap="square">
+            <a:spAutoFit/>
+          </a:bodyPr>
+          <a:lstStyle/>
+          <a:p>
+            <a:pPr algn="l"/>
+            <a:r>
+              <a:rPr sz="1000" b="0" i="0">
+                <a:solidFill>
+                  <a:srgbClr val="88AAA8"/>
+                </a:solidFill>
+              </a:rPr>
+              <a:t>Bo Natakhin · Toronto
+$20/issue · first drop
+cooking zine via TikTok</a:t>
+            </a:r>
+          </a:p>
+        </p:txBody>
+      </p:sp>
+      <p:sp>
+        <p:nvSpPr>
+          <p:cNvPr id="41" name="Rounded Rectangle 40"/>
+          <p:cNvSpPr/>
+          <p:nvPr/>
+        </p:nvSpPr>
+        <p:spPr>
+          <a:xfrm>
+            <a:off x="9153144" y="3218688"/>
+            <a:ext cx="2788920" cy="1874519"/>
+          </a:xfrm>
+          <a:prstGeom prst="roundRect">
+            <a:avLst>
+              <a:gd name="adj" fmla="val 8000"/>
+            </a:avLst>
+          </a:prstGeom>
+          <a:solidFill>
+            <a:srgbClr val="143E3E"/>
+          </a:solidFill>
+          <a:ln>
+            <a:noFill/>
+          </a:ln>
+        </p:spPr>
+        <p:style>
+          <a:lnRef idx="1">
+            <a:schemeClr val="accent1"/>
+          </a:lnRef>
+          <a:fillRef idx="3">
+            <a:schemeClr val="accent1"/>
+          </a:fillRef>
+          <a:effectRef idx="2">
+            <a:schemeClr val="accent1"/>
+          </a:effectRef>
+          <a:fontRef idx="minor">
+            <a:schemeClr val="lt1"/>
+          </a:fontRef>
+        </p:style>
+        <p:txBody>
+          <a:bodyPr rtlCol="0" anchor="ctr"/>
+          <a:lstStyle/>
+          <a:p>
+            <a:pPr algn="ctr"/>
+          </a:p>
+        </p:txBody>
+      </p:sp>
+      <p:sp>
+        <p:nvSpPr>
+          <p:cNvPr id="42" name="Rectangle 41"/>
+          <p:cNvSpPr/>
+          <p:nvPr/>
+        </p:nvSpPr>
+        <p:spPr>
+          <a:xfrm>
+            <a:off x="9153144" y="3218688"/>
+            <a:ext cx="2788920" cy="45720"/>
+          </a:xfrm>
+          <a:prstGeom prst="rect">
+            <a:avLst/>
+          </a:prstGeom>
+          <a:solidFill>
+            <a:srgbClr val="4CC8C3"/>
+          </a:solidFill>
+          <a:ln>
+            <a:noFill/>
+          </a:ln>
+        </p:spPr>
+        <p:style>
+          <a:lnRef idx="1">
+            <a:schemeClr val="accent1"/>
+          </a:lnRef>
+          <a:fillRef idx="3">
+            <a:schemeClr val="accent1"/>
+          </a:fillRef>
+          <a:effectRef idx="2">
+            <a:schemeClr val="accent1"/>
+          </a:effectRef>
+          <a:fontRef idx="minor">
+            <a:schemeClr val="lt1"/>
+          </a:fontRef>
+        </p:style>
+        <p:txBody>
+          <a:bodyPr rtlCol="0" anchor="ctr"/>
+          <a:lstStyle/>
+          <a:p>
+            <a:pPr algn="ctr"/>
+          </a:p>
+        </p:txBody>
+      </p:sp>
+      <p:sp>
+        <p:nvSpPr>
+          <p:cNvPr id="43" name="TextBox 42"/>
+          <p:cNvSpPr txBox="1"/>
+          <p:nvPr/>
+        </p:nvSpPr>
+        <p:spPr>
+          <a:xfrm>
+            <a:off x="9290304" y="3310128"/>
+            <a:ext cx="502920" cy="502920"/>
+          </a:xfrm>
+          <a:prstGeom prst="rect">
+            <a:avLst/>
+          </a:prstGeom>
+          <a:noFill/>
+        </p:spPr>
+        <p:txBody>
+          <a:bodyPr wrap="square">
+            <a:spAutoFit/>
+          </a:bodyPr>
+          <a:lstStyle/>
+          <a:p>
+            <a:pPr algn="l"/>
+            <a:r>
+              <a:rPr sz="2600" b="0" i="0">
+                <a:solidFill>
+                  <a:srgbClr val="FFFFFF"/>
+                </a:solidFill>
+              </a:rPr>
+              <a:t>🚦</a:t>
+            </a:r>
+          </a:p>
+        </p:txBody>
+      </p:sp>
+      <p:sp>
+        <p:nvSpPr>
+          <p:cNvPr id="44" name="TextBox 43"/>
+          <p:cNvSpPr txBox="1"/>
+          <p:nvPr/>
+        </p:nvSpPr>
+        <p:spPr>
+          <a:xfrm>
+            <a:off x="9811512" y="3310128"/>
+            <a:ext cx="2011680" cy="502920"/>
+          </a:xfrm>
+          <a:prstGeom prst="rect">
+            <a:avLst/>
+          </a:prstGeom>
+          <a:noFill/>
+        </p:spPr>
+        <p:txBody>
+          <a:bodyPr wrap="square">
+            <a:spAutoFit/>
+          </a:bodyPr>
+          <a:lstStyle/>
+          <a:p>
+            <a:pPr algn="l"/>
+            <a:r>
+              <a:rPr sz="2200" b="1" i="0">
+                <a:solidFill>
+                  <a:srgbClr val="4CC8C3"/>
+                </a:solidFill>
+              </a:rPr>
+              <a:t>$14K/mo</a:t>
+            </a:r>
+          </a:p>
+        </p:txBody>
+      </p:sp>
+      <p:sp>
+        <p:nvSpPr>
+          <p:cNvPr id="45" name="TextBox 44"/>
+          <p:cNvSpPr txBox="1"/>
+          <p:nvPr/>
+        </p:nvSpPr>
+        <p:spPr>
+          <a:xfrm>
+            <a:off x="9290304" y="3813048"/>
+            <a:ext cx="2514600" cy="365760"/>
+          </a:xfrm>
+          <a:prstGeom prst="rect">
+            <a:avLst/>
+          </a:prstGeom>
+          <a:noFill/>
+        </p:spPr>
+        <p:txBody>
+          <a:bodyPr wrap="square">
+            <a:spAutoFit/>
+          </a:bodyPr>
+          <a:lstStyle/>
+          <a:p>
+            <a:pPr algn="l"/>
+            <a:r>
+              <a:rPr sz="1300" b="1" i="0">
+                <a:solidFill>
+                  <a:srgbClr val="FFFFFF"/>
+                </a:solidFill>
+              </a:rPr>
+              <a:t>The Cloud Report</a:t>
+            </a:r>
+          </a:p>
+        </p:txBody>
+      </p:sp>
+      <p:sp>
+        <p:nvSpPr>
+          <p:cNvPr id="46" name="TextBox 45"/>
+          <p:cNvSpPr txBox="1"/>
+          <p:nvPr/>
+        </p:nvSpPr>
+        <p:spPr>
+          <a:xfrm>
+            <a:off x="9290304" y="4178808"/>
+            <a:ext cx="2514600" cy="804672"/>
+          </a:xfrm>
+          <a:prstGeom prst="rect">
+            <a:avLst/>
+          </a:prstGeom>
+          <a:noFill/>
+        </p:spPr>
+        <p:txBody>
+          <a:bodyPr wrap="square">
+            <a:spAutoFit/>
+          </a:bodyPr>
+          <a:lstStyle/>
+          <a:p>
+            <a:pPr algn="l"/>
+            <a:r>
+              <a:rPr sz="1000" b="0" i="0">
+                <a:solidFill>
+                  <a:srgbClr val="88AAA8"/>
+                </a:solidFill>
+              </a:rPr>
+              <a:t>Christine Tyler Hill · Vermont
+Crossing guard → 2,000 subs
+3,600 on waitlist at launch</a:t>
+            </a:r>
+          </a:p>
+        </p:txBody>
+      </p:sp>
+      <p:sp>
+        <p:nvSpPr>
+          <p:cNvPr id="47" name="TextBox 46"/>
+          <p:cNvSpPr txBox="1"/>
+          <p:nvPr/>
+        </p:nvSpPr>
+        <p:spPr>
+          <a:xfrm>
+            <a:off x="457200" y="5166360"/>
+            <a:ext cx="9144000" cy="292608"/>
+          </a:xfrm>
+          <a:prstGeom prst="rect">
+            <a:avLst/>
+          </a:prstGeom>
+          <a:noFill/>
+        </p:spPr>
+        <p:txBody>
+          <a:bodyPr wrap="square">
+            <a:spAutoFit/>
+          </a:bodyPr>
+          <a:lstStyle/>
+          <a:p>
+            <a:pPr algn="l"/>
+            <a:r>
+              <a:rPr sz="900" b="1" i="0">
+                <a:solidFill>
+                  <a:srgbClr val="4CC8C3"/>
+                </a:solidFill>
+              </a:rPr>
+              <a:t>COMMUNITY PROOF  ·  PEOPLE ALREADY CHOOSE REAL MAIL</a:t>
+            </a:r>
+          </a:p>
+        </p:txBody>
+      </p:sp>
+      <p:sp>
+        <p:nvSpPr>
+          <p:cNvPr id="48" name="Rounded Rectangle 47"/>
+          <p:cNvSpPr/>
+          <p:nvPr/>
+        </p:nvSpPr>
+        <p:spPr>
+          <a:xfrm>
+            <a:off x="457200" y="5486400"/>
+            <a:ext cx="2788920" cy="1261872"/>
+          </a:xfrm>
+          <a:prstGeom prst="roundRect">
+            <a:avLst>
+              <a:gd name="adj" fmla="val 8000"/>
+            </a:avLst>
+          </a:prstGeom>
+          <a:solidFill>
+            <a:srgbClr val="0E2828"/>
+          </a:solidFill>
+          <a:ln>
+            <a:noFill/>
+          </a:ln>
+        </p:spPr>
+        <p:style>
+          <a:lnRef idx="1">
+            <a:schemeClr val="accent1"/>
+          </a:lnRef>
+          <a:fillRef idx="3">
+            <a:schemeClr val="accent1"/>
+          </a:fillRef>
+          <a:effectRef idx="2">
+            <a:schemeClr val="accent1"/>
+          </a:effectRef>
+          <a:fontRef idx="minor">
+            <a:schemeClr val="lt1"/>
+          </a:fontRef>
+        </p:style>
+        <p:txBody>
+          <a:bodyPr rtlCol="0" anchor="ctr"/>
+          <a:lstStyle/>
+          <a:p>
+            <a:pPr algn="ctr"/>
+          </a:p>
+        </p:txBody>
+      </p:sp>
+      <p:sp>
+        <p:nvSpPr>
+          <p:cNvPr id="49" name="TextBox 48"/>
+          <p:cNvSpPr txBox="1"/>
+          <p:nvPr/>
+        </p:nvSpPr>
+        <p:spPr>
+          <a:xfrm>
+            <a:off x="566928" y="5623560"/>
+            <a:ext cx="548640" cy="548640"/>
+          </a:xfrm>
+          <a:prstGeom prst="rect">
+            <a:avLst/>
+          </a:prstGeom>
+          <a:noFill/>
+        </p:spPr>
+        <p:txBody>
+          <a:bodyPr wrap="square">
+            <a:spAutoFit/>
+          </a:bodyPr>
+          <a:lstStyle/>
+          <a:p>
+            <a:pPr algn="l"/>
+            <a:r>
+              <a:rPr sz="2400" b="0" i="0">
+                <a:solidFill>
+                  <a:srgbClr val="FFFFFF"/>
+                </a:solidFill>
+              </a:rPr>
+              <a:t>📮</a:t>
+            </a:r>
+          </a:p>
+        </p:txBody>
+      </p:sp>
+      <p:sp>
+        <p:nvSpPr>
+          <p:cNvPr id="50" name="TextBox 49"/>
+          <p:cNvSpPr txBox="1"/>
+          <p:nvPr/>
+        </p:nvSpPr>
+        <p:spPr>
+          <a:xfrm>
+            <a:off x="1143000" y="5577840"/>
+            <a:ext cx="1965960" cy="658368"/>
+          </a:xfrm>
+          <a:prstGeom prst="rect">
+            <a:avLst/>
+          </a:prstGeom>
+          <a:noFill/>
+        </p:spPr>
+        <p:txBody>
+          <a:bodyPr wrap="square">
+            <a:spAutoFit/>
+          </a:bodyPr>
+          <a:lstStyle/>
+          <a:p>
+            <a:pPr algn="l"/>
+            <a:r>
+              <a:rPr sz="1200" b="1" i="0">
+                <a:solidFill>
+                  <a:srgbClr val="A0E1DF"/>
+                </a:solidFill>
+              </a:rPr>
+              <a:t>806K members
+87M+ postcards</a:t>
+            </a:r>
+          </a:p>
+        </p:txBody>
+      </p:sp>
+      <p:sp>
+        <p:nvSpPr>
+          <p:cNvPr id="51" name="TextBox 50"/>
+          <p:cNvSpPr txBox="1"/>
+          <p:nvPr/>
+        </p:nvSpPr>
+        <p:spPr>
+          <a:xfrm>
+            <a:off x="1143000" y="6236208"/>
+            <a:ext cx="2011680" cy="347472"/>
+          </a:xfrm>
+          <a:prstGeom prst="rect">
+            <a:avLst/>
+          </a:prstGeom>
+          <a:noFill/>
+        </p:spPr>
+        <p:txBody>
+          <a:bodyPr wrap="square">
+            <a:spAutoFit/>
+          </a:bodyPr>
+          <a:lstStyle/>
+          <a:p>
+            <a:pPr algn="l"/>
+            <a:r>
+              <a:rPr sz="1000" b="0" i="0">
+                <a:solidFill>
+                  <a:srgbClr val="88AAA8"/>
+                </a:solidFill>
+              </a:rPr>
+              <a:t>Postcrossing</a:t>
+            </a:r>
+          </a:p>
+        </p:txBody>
+      </p:sp>
+      <p:sp>
+        <p:nvSpPr>
+          <p:cNvPr id="52" name="Rounded Rectangle 51"/>
+          <p:cNvSpPr/>
+          <p:nvPr/>
+        </p:nvSpPr>
+        <p:spPr>
+          <a:xfrm>
+            <a:off x="3355848" y="5486400"/>
+            <a:ext cx="2788920" cy="1261872"/>
+          </a:xfrm>
+          <a:prstGeom prst="roundRect">
+            <a:avLst>
+              <a:gd name="adj" fmla="val 8000"/>
+            </a:avLst>
+          </a:prstGeom>
+          <a:solidFill>
+            <a:srgbClr val="0E2828"/>
+          </a:solidFill>
+          <a:ln>
+            <a:noFill/>
+          </a:ln>
+        </p:spPr>
+        <p:style>
+          <a:lnRef idx="1">
+            <a:schemeClr val="accent1"/>
+          </a:lnRef>
+          <a:fillRef idx="3">
+            <a:schemeClr val="accent1"/>
+          </a:fillRef>
+          <a:effectRef idx="2">
+            <a:schemeClr val="accent1"/>
+          </a:effectRef>
+          <a:fontRef idx="minor">
+            <a:schemeClr val="lt1"/>
+          </a:fontRef>
+        </p:style>
+        <p:txBody>
+          <a:bodyPr rtlCol="0" anchor="ctr"/>
+          <a:lstStyle/>
+          <a:p>
+            <a:pPr algn="ctr"/>
           </a:p>
         </p:txBody>
       </p:sp>
@@ -12843,28 +12880,28 @@
         </p:nvSpPr>
         <p:spPr>
           <a:xfrm>
-            <a:off x="9061702" y="4544568"/>
-            <a:ext cx="1325880" cy="530352"/>
-          </a:xfrm>
-          <a:prstGeom prst="rect">
-            <a:avLst/>
-          </a:prstGeom>
-          <a:noFill/>
-        </p:spPr>
-        <p:txBody>
-          <a:bodyPr wrap="square">
-            <a:spAutoFit/>
-          </a:bodyPr>
-          <a:lstStyle/>
-          <a:p>
-            <a:pPr algn="l"/>
-            <a:r>
-              <a:rPr sz="3000" b="1" i="0">
-                <a:solidFill>
-                  <a:srgbClr val="4CC8C3"/>
-                </a:solidFill>
-              </a:rPr>
-              <a:t>1,600</a:t>
+            <a:off x="3465576" y="5623560"/>
+            <a:ext cx="548640" cy="548640"/>
+          </a:xfrm>
+          <a:prstGeom prst="rect">
+            <a:avLst/>
+          </a:prstGeom>
+          <a:noFill/>
+        </p:spPr>
+        <p:txBody>
+          <a:bodyPr wrap="square">
+            <a:spAutoFit/>
+          </a:bodyPr>
+          <a:lstStyle/>
+          <a:p>
+            <a:pPr algn="l"/>
+            <a:r>
+              <a:rPr sz="2400" b="0" i="0">
+                <a:solidFill>
+                  <a:srgbClr val="FFFFFF"/>
+                </a:solidFill>
+              </a:rPr>
+              <a:t>💌</a:t>
             </a:r>
           </a:p>
         </p:txBody>
@@ -12877,8 +12914,43 @@
         </p:nvSpPr>
         <p:spPr>
           <a:xfrm>
-            <a:off x="9061702" y="5038344"/>
-            <a:ext cx="1463040" cy="274320"/>
+            <a:off x="4041648" y="5577840"/>
+            <a:ext cx="1965960" cy="658368"/>
+          </a:xfrm>
+          <a:prstGeom prst="rect">
+            <a:avLst/>
+          </a:prstGeom>
+          <a:noFill/>
+        </p:spPr>
+        <p:txBody>
+          <a:bodyPr wrap="square">
+            <a:spAutoFit/>
+          </a:bodyPr>
+          <a:lstStyle/>
+          <a:p>
+            <a:pPr algn="l"/>
+            <a:r>
+              <a:rPr sz="1200" b="1" i="0">
+                <a:solidFill>
+                  <a:srgbClr val="A0E1DF"/>
+                </a:solidFill>
+              </a:rPr>
+              <a:t>1M+ letters
+COVID-era strangers</a:t>
+            </a:r>
+          </a:p>
+        </p:txBody>
+      </p:sp>
+      <p:sp>
+        <p:nvSpPr>
+          <p:cNvPr id="55" name="TextBox 54"/>
+          <p:cNvSpPr txBox="1"/>
+          <p:nvPr/>
+        </p:nvSpPr>
+        <p:spPr>
+          <a:xfrm>
+            <a:off x="4041648" y="6236208"/>
+            <a:ext cx="2011680" cy="347472"/>
           </a:xfrm>
           <a:prstGeom prst="rect">
             <a:avLst/>
@@ -12895,24 +12967,251 @@
             <a:r>
               <a:rPr sz="1000" b="0" i="0">
                 <a:solidFill>
+                  <a:srgbClr val="88AAA8"/>
+                </a:solidFill>
+              </a:rPr>
+              <a:t>Letters Against Isolation</a:t>
+            </a:r>
+          </a:p>
+        </p:txBody>
+      </p:sp>
+      <p:sp>
+        <p:nvSpPr>
+          <p:cNvPr id="56" name="Rounded Rectangle 55"/>
+          <p:cNvSpPr/>
+          <p:nvPr/>
+        </p:nvSpPr>
+        <p:spPr>
+          <a:xfrm>
+            <a:off x="6254496" y="5486400"/>
+            <a:ext cx="2788920" cy="1261872"/>
+          </a:xfrm>
+          <a:prstGeom prst="roundRect">
+            <a:avLst>
+              <a:gd name="adj" fmla="val 8000"/>
+            </a:avLst>
+          </a:prstGeom>
+          <a:solidFill>
+            <a:srgbClr val="0E2828"/>
+          </a:solidFill>
+          <a:ln>
+            <a:noFill/>
+          </a:ln>
+        </p:spPr>
+        <p:style>
+          <a:lnRef idx="1">
+            <a:schemeClr val="accent1"/>
+          </a:lnRef>
+          <a:fillRef idx="3">
+            <a:schemeClr val="accent1"/>
+          </a:fillRef>
+          <a:effectRef idx="2">
+            <a:schemeClr val="accent1"/>
+          </a:effectRef>
+          <a:fontRef idx="minor">
+            <a:schemeClr val="lt1"/>
+          </a:fontRef>
+        </p:style>
+        <p:txBody>
+          <a:bodyPr rtlCol="0" anchor="ctr"/>
+          <a:lstStyle/>
+          <a:p>
+            <a:pPr algn="ctr"/>
+          </a:p>
+        </p:txBody>
+      </p:sp>
+      <p:sp>
+        <p:nvSpPr>
+          <p:cNvPr id="57" name="TextBox 56"/>
+          <p:cNvSpPr txBox="1"/>
+          <p:nvPr/>
+        </p:nvSpPr>
+        <p:spPr>
+          <a:xfrm>
+            <a:off x="6364224" y="5623560"/>
+            <a:ext cx="548640" cy="548640"/>
+          </a:xfrm>
+          <a:prstGeom prst="rect">
+            <a:avLst/>
+          </a:prstGeom>
+          <a:noFill/>
+        </p:spPr>
+        <p:txBody>
+          <a:bodyPr wrap="square">
+            <a:spAutoFit/>
+          </a:bodyPr>
+          <a:lstStyle/>
+          <a:p>
+            <a:pPr algn="l"/>
+            <a:r>
+              <a:rPr sz="2400" b="0" i="0">
+                <a:solidFill>
+                  <a:srgbClr val="FFFFFF"/>
+                </a:solidFill>
+              </a:rPr>
+              <a:t>🤝</a:t>
+            </a:r>
+          </a:p>
+        </p:txBody>
+      </p:sp>
+      <p:sp>
+        <p:nvSpPr>
+          <p:cNvPr id="58" name="TextBox 57"/>
+          <p:cNvSpPr txBox="1"/>
+          <p:nvPr/>
+        </p:nvSpPr>
+        <p:spPr>
+          <a:xfrm>
+            <a:off x="6940296" y="5577840"/>
+            <a:ext cx="1965960" cy="658368"/>
+          </a:xfrm>
+          <a:prstGeom prst="rect">
+            <a:avLst/>
+          </a:prstGeom>
+          <a:noFill/>
+        </p:spPr>
+        <p:txBody>
+          <a:bodyPr wrap="square">
+            <a:spAutoFit/>
+          </a:bodyPr>
+          <a:lstStyle/>
+          <a:p>
+            <a:pPr algn="l"/>
+            <a:r>
+              <a:rPr sz="1200" b="1" i="0">
+                <a:solidFill>
                   <a:srgbClr val="A0E1DF"/>
                 </a:solidFill>
               </a:rPr>
-              <a:t>members in weeks</a:t>
-            </a:r>
-          </a:p>
-        </p:txBody>
-      </p:sp>
-      <p:sp>
-        <p:nvSpPr>
-          <p:cNvPr id="55" name="TextBox 54"/>
-          <p:cNvSpPr txBox="1"/>
-          <p:nvPr/>
-        </p:nvSpPr>
-        <p:spPr>
-          <a:xfrm>
-            <a:off x="10433302" y="4544568"/>
-            <a:ext cx="1508760" cy="347472"/>
+              <a:t>1M+ letters
+100+ chapters, 70+ mailboxes</a:t>
+            </a:r>
+          </a:p>
+        </p:txBody>
+      </p:sp>
+      <p:sp>
+        <p:nvSpPr>
+          <p:cNvPr id="59" name="TextBox 58"/>
+          <p:cNvSpPr txBox="1"/>
+          <p:nvPr/>
+        </p:nvSpPr>
+        <p:spPr>
+          <a:xfrm>
+            <a:off x="6940296" y="6236208"/>
+            <a:ext cx="2011680" cy="347472"/>
+          </a:xfrm>
+          <a:prstGeom prst="rect">
+            <a:avLst/>
+          </a:prstGeom>
+          <a:noFill/>
+        </p:spPr>
+        <p:txBody>
+          <a:bodyPr wrap="square">
+            <a:spAutoFit/>
+          </a:bodyPr>
+          <a:lstStyle/>
+          <a:p>
+            <a:pPr algn="l"/>
+            <a:r>
+              <a:rPr sz="1000" b="0" i="0">
+                <a:solidFill>
+                  <a:srgbClr val="88AAA8"/>
+                </a:solidFill>
+              </a:rPr>
+              <a:t>Love For Our Elders</a:t>
+            </a:r>
+          </a:p>
+        </p:txBody>
+      </p:sp>
+      <p:sp>
+        <p:nvSpPr>
+          <p:cNvPr id="60" name="Rounded Rectangle 59"/>
+          <p:cNvSpPr/>
+          <p:nvPr/>
+        </p:nvSpPr>
+        <p:spPr>
+          <a:xfrm>
+            <a:off x="9153144" y="5486400"/>
+            <a:ext cx="2788920" cy="1261872"/>
+          </a:xfrm>
+          <a:prstGeom prst="roundRect">
+            <a:avLst>
+              <a:gd name="adj" fmla="val 8000"/>
+            </a:avLst>
+          </a:prstGeom>
+          <a:solidFill>
+            <a:srgbClr val="0E2828"/>
+          </a:solidFill>
+          <a:ln>
+            <a:noFill/>
+          </a:ln>
+        </p:spPr>
+        <p:style>
+          <a:lnRef idx="1">
+            <a:schemeClr val="accent1"/>
+          </a:lnRef>
+          <a:fillRef idx="3">
+            <a:schemeClr val="accent1"/>
+          </a:fillRef>
+          <a:effectRef idx="2">
+            <a:schemeClr val="accent1"/>
+          </a:effectRef>
+          <a:fontRef idx="minor">
+            <a:schemeClr val="lt1"/>
+          </a:fontRef>
+        </p:style>
+        <p:txBody>
+          <a:bodyPr rtlCol="0" anchor="ctr"/>
+          <a:lstStyle/>
+          <a:p>
+            <a:pPr algn="ctr"/>
+          </a:p>
+        </p:txBody>
+      </p:sp>
+      <p:sp>
+        <p:nvSpPr>
+          <p:cNvPr id="61" name="TextBox 60"/>
+          <p:cNvSpPr txBox="1"/>
+          <p:nvPr/>
+        </p:nvSpPr>
+        <p:spPr>
+          <a:xfrm>
+            <a:off x="9262872" y="5623560"/>
+            <a:ext cx="548640" cy="548640"/>
+          </a:xfrm>
+          <a:prstGeom prst="rect">
+            <a:avLst/>
+          </a:prstGeom>
+          <a:noFill/>
+        </p:spPr>
+        <p:txBody>
+          <a:bodyPr wrap="square">
+            <a:spAutoFit/>
+          </a:bodyPr>
+          <a:lstStyle/>
+          <a:p>
+            <a:pPr algn="l"/>
+            <a:r>
+              <a:rPr sz="2400" b="0" i="0">
+                <a:solidFill>
+                  <a:srgbClr val="FFFFFF"/>
+                </a:solidFill>
+              </a:rPr>
+              <a:t>🌍</a:t>
+            </a:r>
+          </a:p>
+        </p:txBody>
+      </p:sp>
+      <p:sp>
+        <p:nvSpPr>
+          <p:cNvPr id="62" name="TextBox 61"/>
+          <p:cNvSpPr txBox="1"/>
+          <p:nvPr/>
+        </p:nvSpPr>
+        <p:spPr>
+          <a:xfrm>
+            <a:off x="9838944" y="5577840"/>
+            <a:ext cx="1965960" cy="658368"/>
           </a:xfrm>
           <a:prstGeom prst="rect">
             <a:avLst/>
@@ -12929,24 +13228,25 @@
             <a:r>
               <a:rPr sz="1200" b="1" i="0">
                 <a:solidFill>
-                  <a:srgbClr val="FFFFFF"/>
-                </a:solidFill>
-              </a:rPr>
-              <a:t>Analog Life Snail Society</a:t>
-            </a:r>
-          </a:p>
-        </p:txBody>
-      </p:sp>
-      <p:sp>
-        <p:nvSpPr>
-          <p:cNvPr id="56" name="TextBox 55"/>
-          <p:cNvSpPr txBox="1"/>
-          <p:nvPr/>
-        </p:nvSpPr>
-        <p:spPr>
-          <a:xfrm>
-            <a:off x="10433302" y="4910328"/>
-            <a:ext cx="1508760" cy="868680"/>
+                  <a:srgbClr val="A0E1DF"/>
+                </a:solidFill>
+              </a:rPr>
+              <a:t>All 50 states
+70+ countries active</a:t>
+            </a:r>
+          </a:p>
+        </p:txBody>
+      </p:sp>
+      <p:sp>
+        <p:nvSpPr>
+          <p:cNvPr id="63" name="TextBox 62"/>
+          <p:cNvSpPr txBox="1"/>
+          <p:nvPr/>
+        </p:nvSpPr>
+        <p:spPr>
+          <a:xfrm>
+            <a:off x="9838944" y="6236208"/>
+            <a:ext cx="2011680" cy="347472"/>
           </a:xfrm>
           <a:prstGeom prst="rect">
             <a:avLst/>
@@ -12966,49 +13266,14 @@
                   <a:srgbClr val="88AAA8"/>
                 </a:solidFill>
               </a:rPr>
-              <a:t>Grew from 25 to 1,600
-members in one month</a:t>
-            </a:r>
-          </a:p>
-        </p:txBody>
-      </p:sp>
-      <p:sp>
-        <p:nvSpPr>
-          <p:cNvPr id="57" name="TextBox 56"/>
-          <p:cNvSpPr txBox="1"/>
-          <p:nvPr/>
-        </p:nvSpPr>
-        <p:spPr>
-          <a:xfrm>
-            <a:off x="457200" y="6492240"/>
-            <a:ext cx="11247120" cy="292608"/>
-          </a:xfrm>
-          <a:prstGeom prst="rect">
-            <a:avLst/>
-          </a:prstGeom>
-          <a:noFill/>
-        </p:spPr>
-        <p:txBody>
-          <a:bodyPr wrap="square">
-            <a:spAutoFit/>
-          </a:bodyPr>
-          <a:lstStyle/>
-          <a:p>
-            <a:pPr algn="l"/>
-            <a:r>
-              <a:rPr sz="1200" b="0" i="1">
-                <a:solidFill>
-                  <a:srgbClr val="A0E1DF"/>
-                </a:solidFill>
-              </a:rPr>
-              <a:t>✦  Real mail isn't nostalgic — it's powerful. Kids just haven't had it built for them.</a:t>
-            </a:r>
-          </a:p>
-        </p:txBody>
-      </p:sp>
-      <p:sp>
-        <p:nvSpPr>
-          <p:cNvPr id="58" name="TextBox 57"/>
+              <a:t>More Love Letters</a:t>
+            </a:r>
+          </a:p>
+        </p:txBody>
+      </p:sp>
+      <p:sp>
+        <p:nvSpPr>
+          <p:cNvPr id="64" name="TextBox 63"/>
           <p:cNvSpPr txBox="1"/>
           <p:nvPr/>
         </p:nvSpPr>

</xml_diff>